<commit_message>
Remove subject from preprocessing
</commit_message>
<xml_diff>
--- a/fake-news-classifier.pptx
+++ b/fake-news-classifier.pptx
@@ -19,14 +19,15 @@
     <p:sldId id="264" r:id="rId13"/>
     <p:sldId id="269" r:id="rId14"/>
     <p:sldId id="270" r:id="rId15"/>
-    <p:sldId id="272" r:id="rId16"/>
-    <p:sldId id="271" r:id="rId17"/>
-    <p:sldId id="273" r:id="rId18"/>
-    <p:sldId id="274" r:id="rId19"/>
-    <p:sldId id="275" r:id="rId20"/>
-    <p:sldId id="276" r:id="rId21"/>
-    <p:sldId id="277" r:id="rId22"/>
-    <p:sldId id="265" r:id="rId23"/>
+    <p:sldId id="278" r:id="rId16"/>
+    <p:sldId id="272" r:id="rId17"/>
+    <p:sldId id="271" r:id="rId18"/>
+    <p:sldId id="273" r:id="rId19"/>
+    <p:sldId id="274" r:id="rId20"/>
+    <p:sldId id="275" r:id="rId21"/>
+    <p:sldId id="276" r:id="rId22"/>
+    <p:sldId id="277" r:id="rId23"/>
+    <p:sldId id="265" r:id="rId24"/>
   </p:sldIdLst>
   <p:sldSz cx="9144000" cy="6858000" type="screen4x3"/>
   <p:notesSz cx="6858000" cy="9144000"/>
@@ -323,7 +324,7 @@
           <a:p>
             <a:fld id="{5BCAD085-E8A6-8845-BD4E-CB4CCA059FC4}" type="datetimeFigureOut">
               <a:rPr lang="en-US" smtClean="0"/>
-              <a:t>1/20/2026</a:t>
+              <a:t>1/21/2026</a:t>
             </a:fld>
             <a:endParaRPr lang="en-US"/>
           </a:p>
@@ -491,7 +492,7 @@
           <a:p>
             <a:fld id="{5BCAD085-E8A6-8845-BD4E-CB4CCA059FC4}" type="datetimeFigureOut">
               <a:rPr lang="en-US" smtClean="0"/>
-              <a:t>1/20/2026</a:t>
+              <a:t>1/21/2026</a:t>
             </a:fld>
             <a:endParaRPr lang="en-US"/>
           </a:p>
@@ -669,7 +670,7 @@
           <a:p>
             <a:fld id="{5BCAD085-E8A6-8845-BD4E-CB4CCA059FC4}" type="datetimeFigureOut">
               <a:rPr lang="en-US" smtClean="0"/>
-              <a:t>1/20/2026</a:t>
+              <a:t>1/21/2026</a:t>
             </a:fld>
             <a:endParaRPr lang="en-US"/>
           </a:p>
@@ -837,7 +838,7 @@
           <a:p>
             <a:fld id="{5BCAD085-E8A6-8845-BD4E-CB4CCA059FC4}" type="datetimeFigureOut">
               <a:rPr lang="en-US" smtClean="0"/>
-              <a:t>1/20/2026</a:t>
+              <a:t>1/21/2026</a:t>
             </a:fld>
             <a:endParaRPr lang="en-US"/>
           </a:p>
@@ -1082,7 +1083,7 @@
           <a:p>
             <a:fld id="{5BCAD085-E8A6-8845-BD4E-CB4CCA059FC4}" type="datetimeFigureOut">
               <a:rPr lang="en-US" smtClean="0"/>
-              <a:t>1/20/2026</a:t>
+              <a:t>1/21/2026</a:t>
             </a:fld>
             <a:endParaRPr lang="en-US"/>
           </a:p>
@@ -1367,7 +1368,7 @@
           <a:p>
             <a:fld id="{5BCAD085-E8A6-8845-BD4E-CB4CCA059FC4}" type="datetimeFigureOut">
               <a:rPr lang="en-US" smtClean="0"/>
-              <a:t>1/20/2026</a:t>
+              <a:t>1/21/2026</a:t>
             </a:fld>
             <a:endParaRPr lang="en-US"/>
           </a:p>
@@ -1786,7 +1787,7 @@
           <a:p>
             <a:fld id="{5BCAD085-E8A6-8845-BD4E-CB4CCA059FC4}" type="datetimeFigureOut">
               <a:rPr lang="en-US" smtClean="0"/>
-              <a:t>1/20/2026</a:t>
+              <a:t>1/21/2026</a:t>
             </a:fld>
             <a:endParaRPr lang="en-US"/>
           </a:p>
@@ -1903,7 +1904,7 @@
           <a:p>
             <a:fld id="{5BCAD085-E8A6-8845-BD4E-CB4CCA059FC4}" type="datetimeFigureOut">
               <a:rPr lang="en-US" smtClean="0"/>
-              <a:t>1/20/2026</a:t>
+              <a:t>1/21/2026</a:t>
             </a:fld>
             <a:endParaRPr lang="en-US"/>
           </a:p>
@@ -1998,7 +1999,7 @@
           <a:p>
             <a:fld id="{5BCAD085-E8A6-8845-BD4E-CB4CCA059FC4}" type="datetimeFigureOut">
               <a:rPr lang="en-US" smtClean="0"/>
-              <a:t>1/20/2026</a:t>
+              <a:t>1/21/2026</a:t>
             </a:fld>
             <a:endParaRPr lang="en-US"/>
           </a:p>
@@ -2273,7 +2274,7 @@
           <a:p>
             <a:fld id="{5BCAD085-E8A6-8845-BD4E-CB4CCA059FC4}" type="datetimeFigureOut">
               <a:rPr lang="en-US" smtClean="0"/>
-              <a:t>1/20/2026</a:t>
+              <a:t>1/21/2026</a:t>
             </a:fld>
             <a:endParaRPr lang="en-US"/>
           </a:p>
@@ -2525,7 +2526,7 @@
           <a:p>
             <a:fld id="{5BCAD085-E8A6-8845-BD4E-CB4CCA059FC4}" type="datetimeFigureOut">
               <a:rPr lang="en-US" smtClean="0"/>
-              <a:t>1/20/2026</a:t>
+              <a:t>1/21/2026</a:t>
             </a:fld>
             <a:endParaRPr lang="en-US"/>
           </a:p>
@@ -2736,7 +2737,7 @@
           <a:p>
             <a:fld id="{5BCAD085-E8A6-8845-BD4E-CB4CCA059FC4}" type="datetimeFigureOut">
               <a:rPr lang="en-US" smtClean="0"/>
-              <a:t>1/20/2026</a:t>
+              <a:t>1/21/2026</a:t>
             </a:fld>
             <a:endParaRPr lang="en-US"/>
           </a:p>
@@ -3616,7 +3617,7 @@
           <a:p>
             <a:r>
               <a:rPr lang="en-US" sz="9600" dirty="0"/>
-              <a:t>Title, text and subject are considered (subject with one hot encoding)</a:t>
+              <a:t>Title and text are considered</a:t>
             </a:r>
           </a:p>
           <a:p>
@@ -3791,42 +3792,6 @@
       </p:sp>
       <p:sp>
         <p:nvSpPr>
-          <p:cNvPr id="6" name="CuadroTexto 5">
-            <a:extLst>
-              <a:ext uri="{FF2B5EF4-FFF2-40B4-BE49-F238E27FC236}">
-                <a16:creationId xmlns:a16="http://schemas.microsoft.com/office/drawing/2014/main" id="{C640E110-128F-5B68-0C52-AFDDE47AD90B}"/>
-              </a:ext>
-            </a:extLst>
-          </p:cNvPr>
-          <p:cNvSpPr txBox="1"/>
-          <p:nvPr/>
-        </p:nvSpPr>
-        <p:spPr>
-          <a:xfrm>
-            <a:off x="4080389" y="1587461"/>
-            <a:ext cx="2861185" cy="523220"/>
-          </a:xfrm>
-          <a:prstGeom prst="rect">
-            <a:avLst/>
-          </a:prstGeom>
-          <a:noFill/>
-        </p:spPr>
-        <p:txBody>
-          <a:bodyPr wrap="square" rtlCol="0">
-            <a:spAutoFit/>
-          </a:bodyPr>
-          <a:lstStyle/>
-          <a:p>
-            <a:r>
-              <a:rPr lang="en-US" sz="2800" dirty="0"/>
-              <a:t>SVM with tuning</a:t>
-            </a:r>
-            <a:endParaRPr lang="en-GB" sz="2800" dirty="0"/>
-          </a:p>
-        </p:txBody>
-      </p:sp>
-      <p:sp>
-        <p:nvSpPr>
           <p:cNvPr id="7" name="CuadroTexto 6">
             <a:extLst>
               <a:ext uri="{FF2B5EF4-FFF2-40B4-BE49-F238E27FC236}">
@@ -3855,23 +3820,23 @@
           <a:p>
             <a:r>
               <a:rPr lang="en-GB" sz="2400" dirty="0"/>
-              <a:t>Accuracy: 0.9977 </a:t>
+              <a:t>Accuracy: 0.9945 </a:t>
             </a:r>
           </a:p>
           <a:p>
             <a:r>
               <a:rPr lang="en-GB" sz="2400" dirty="0"/>
-              <a:t>MCC: 0.9953</a:t>
+              <a:t>MCC: 0.9891</a:t>
             </a:r>
           </a:p>
         </p:txBody>
       </p:sp>
       <p:graphicFrame>
         <p:nvGraphicFramePr>
-          <p:cNvPr id="8" name="Tabla 7">
+          <p:cNvPr id="2" name="Tabla 1">
             <a:extLst>
               <a:ext uri="{FF2B5EF4-FFF2-40B4-BE49-F238E27FC236}">
-                <a16:creationId xmlns:a16="http://schemas.microsoft.com/office/drawing/2014/main" id="{D6142A35-657D-C758-CB68-06E3C5F243E5}"/>
+                <a16:creationId xmlns:a16="http://schemas.microsoft.com/office/drawing/2014/main" id="{F0CAF4DA-3082-5645-FFC6-4C6FB2D01C65}"/>
               </a:ext>
             </a:extLst>
           </p:cNvPr>
@@ -3881,13 +3846,13 @@
           <p:nvPr>
             <p:extLst>
               <p:ext uri="{D42A27DB-BD31-4B8C-83A1-F6EECF244321}">
-                <p14:modId xmlns:p14="http://schemas.microsoft.com/office/powerpoint/2010/main" val="2473977974"/>
+                <p14:modId xmlns:p14="http://schemas.microsoft.com/office/powerpoint/2010/main" val="1902010008"/>
               </p:ext>
             </p:extLst>
           </p:nvPr>
         </p:nvGraphicFramePr>
         <p:xfrm>
-          <a:off x="1505563" y="3747207"/>
+          <a:off x="2814480" y="3214346"/>
           <a:ext cx="5641260" cy="2468880"/>
         </p:xfrm>
         <a:graphic>
@@ -4327,7 +4292,7 @@
                       </a:pPr>
                       <a:r>
                         <a:rPr lang="en-GB" dirty="0"/>
-                        <a:t>1.00</a:t>
+                        <a:t>0.99</a:t>
                       </a:r>
                     </a:p>
                   </a:txBody>
@@ -4380,8 +4345,8 @@
                         <a:buNone/>
                       </a:pPr>
                       <a:r>
-                        <a:rPr lang="en-GB"/>
-                        <a:t>1.00</a:t>
+                        <a:rPr lang="en-GB" dirty="0"/>
+                        <a:t>0.99</a:t>
                       </a:r>
                     </a:p>
                   </a:txBody>
@@ -4550,7 +4515,7 @@
                       </a:pPr>
                       <a:r>
                         <a:rPr lang="en-GB" dirty="0"/>
-                        <a:t>1.00</a:t>
+                        <a:t>0.99</a:t>
                       </a:r>
                     </a:p>
                   </a:txBody>
@@ -4603,7 +4568,7 @@
                         <a:buNone/>
                       </a:pPr>
                       <a:r>
-                        <a:rPr lang="en-GB"/>
+                        <a:rPr lang="en-GB" dirty="0"/>
                         <a:t>1.00</a:t>
                       </a:r>
                     </a:p>
@@ -4657,8 +4622,8 @@
                         <a:buNone/>
                       </a:pPr>
                       <a:r>
-                        <a:rPr lang="en-GB"/>
-                        <a:t>1.00</a:t>
+                        <a:rPr lang="en-GB" dirty="0"/>
+                        <a:t>0.99</a:t>
                       </a:r>
                     </a:p>
                   </a:txBody>
@@ -4936,7 +4901,7 @@
                       </a:pPr>
                       <a:r>
                         <a:rPr lang="en-GB" dirty="0"/>
-                        <a:t>1.00</a:t>
+                        <a:t>0.99</a:t>
                       </a:r>
                     </a:p>
                   </a:txBody>
@@ -5050,10 +5015,802 @@
                         <a:buNone/>
                       </a:pPr>
                       <a:r>
-                        <a:rPr lang="en-GB" b="1"/>
-                        <a:t>Macro Avg</a:t>
+                        <a:rPr lang="en-GB" b="1" dirty="0"/>
+                        <a:t>Macro </a:t>
                       </a:r>
-                      <a:endParaRPr lang="en-GB"/>
+                      <a:r>
+                        <a:rPr lang="en-GB" b="1" dirty="0" err="1"/>
+                        <a:t>Avg</a:t>
+                      </a:r>
+                      <a:endParaRPr lang="en-GB" dirty="0"/>
+                    </a:p>
+                  </a:txBody>
+                  <a:tcPr anchor="ctr">
+                    <a:lnL w="12700" cap="flat" cmpd="sng" algn="ctr">
+                      <a:solidFill>
+                        <a:schemeClr val="tx1"/>
+                      </a:solidFill>
+                      <a:prstDash val="solid"/>
+                      <a:round/>
+                      <a:headEnd type="none" w="med" len="med"/>
+                      <a:tailEnd type="none" w="med" len="med"/>
+                    </a:lnL>
+                    <a:lnR w="12700" cap="flat" cmpd="sng" algn="ctr">
+                      <a:solidFill>
+                        <a:schemeClr val="tx1"/>
+                      </a:solidFill>
+                      <a:prstDash val="solid"/>
+                      <a:round/>
+                      <a:headEnd type="none" w="med" len="med"/>
+                      <a:tailEnd type="none" w="med" len="med"/>
+                    </a:lnR>
+                    <a:lnT w="12700" cap="flat" cmpd="sng" algn="ctr">
+                      <a:solidFill>
+                        <a:schemeClr val="tx1"/>
+                      </a:solidFill>
+                      <a:prstDash val="solid"/>
+                      <a:round/>
+                      <a:headEnd type="none" w="med" len="med"/>
+                      <a:tailEnd type="none" w="med" len="med"/>
+                    </a:lnT>
+                    <a:lnB w="12700" cap="flat" cmpd="sng" algn="ctr">
+                      <a:solidFill>
+                        <a:schemeClr val="tx1"/>
+                      </a:solidFill>
+                      <a:prstDash val="solid"/>
+                      <a:round/>
+                      <a:headEnd type="none" w="med" len="med"/>
+                      <a:tailEnd type="none" w="med" len="med"/>
+                    </a:lnB>
+                    <a:noFill/>
+                  </a:tcPr>
+                </a:tc>
+                <a:tc>
+                  <a:txBody>
+                    <a:bodyPr/>
+                    <a:lstStyle/>
+                    <a:p>
+                      <a:pPr>
+                        <a:buNone/>
+                      </a:pPr>
+                      <a:r>
+                        <a:rPr lang="en-GB" dirty="0"/>
+                        <a:t>0.99</a:t>
+                      </a:r>
+                    </a:p>
+                  </a:txBody>
+                  <a:tcPr anchor="ctr">
+                    <a:lnL w="12700" cap="flat" cmpd="sng" algn="ctr">
+                      <a:solidFill>
+                        <a:schemeClr val="tx1"/>
+                      </a:solidFill>
+                      <a:prstDash val="solid"/>
+                      <a:round/>
+                      <a:headEnd type="none" w="med" len="med"/>
+                      <a:tailEnd type="none" w="med" len="med"/>
+                    </a:lnL>
+                    <a:lnR w="12700" cap="flat" cmpd="sng" algn="ctr">
+                      <a:solidFill>
+                        <a:schemeClr val="tx1"/>
+                      </a:solidFill>
+                      <a:prstDash val="solid"/>
+                      <a:round/>
+                      <a:headEnd type="none" w="med" len="med"/>
+                      <a:tailEnd type="none" w="med" len="med"/>
+                    </a:lnR>
+                    <a:lnT w="12700" cap="flat" cmpd="sng" algn="ctr">
+                      <a:solidFill>
+                        <a:schemeClr val="tx1"/>
+                      </a:solidFill>
+                      <a:prstDash val="solid"/>
+                      <a:round/>
+                      <a:headEnd type="none" w="med" len="med"/>
+                      <a:tailEnd type="none" w="med" len="med"/>
+                    </a:lnT>
+                    <a:lnB w="12700" cap="flat" cmpd="sng" algn="ctr">
+                      <a:solidFill>
+                        <a:schemeClr val="tx1"/>
+                      </a:solidFill>
+                      <a:prstDash val="solid"/>
+                      <a:round/>
+                      <a:headEnd type="none" w="med" len="med"/>
+                      <a:tailEnd type="none" w="med" len="med"/>
+                    </a:lnB>
+                    <a:noFill/>
+                  </a:tcPr>
+                </a:tc>
+                <a:tc>
+                  <a:txBody>
+                    <a:bodyPr/>
+                    <a:lstStyle/>
+                    <a:p>
+                      <a:pPr>
+                        <a:buNone/>
+                      </a:pPr>
+                      <a:r>
+                        <a:rPr lang="en-GB" dirty="0"/>
+                        <a:t>0.99</a:t>
+                      </a:r>
+                    </a:p>
+                  </a:txBody>
+                  <a:tcPr anchor="ctr">
+                    <a:lnL w="12700" cap="flat" cmpd="sng" algn="ctr">
+                      <a:solidFill>
+                        <a:schemeClr val="tx1"/>
+                      </a:solidFill>
+                      <a:prstDash val="solid"/>
+                      <a:round/>
+                      <a:headEnd type="none" w="med" len="med"/>
+                      <a:tailEnd type="none" w="med" len="med"/>
+                    </a:lnL>
+                    <a:lnR w="12700" cap="flat" cmpd="sng" algn="ctr">
+                      <a:solidFill>
+                        <a:schemeClr val="tx1"/>
+                      </a:solidFill>
+                      <a:prstDash val="solid"/>
+                      <a:round/>
+                      <a:headEnd type="none" w="med" len="med"/>
+                      <a:tailEnd type="none" w="med" len="med"/>
+                    </a:lnR>
+                    <a:lnT w="12700" cap="flat" cmpd="sng" algn="ctr">
+                      <a:solidFill>
+                        <a:schemeClr val="tx1"/>
+                      </a:solidFill>
+                      <a:prstDash val="solid"/>
+                      <a:round/>
+                      <a:headEnd type="none" w="med" len="med"/>
+                      <a:tailEnd type="none" w="med" len="med"/>
+                    </a:lnT>
+                    <a:lnB w="12700" cap="flat" cmpd="sng" algn="ctr">
+                      <a:solidFill>
+                        <a:schemeClr val="tx1"/>
+                      </a:solidFill>
+                      <a:prstDash val="solid"/>
+                      <a:round/>
+                      <a:headEnd type="none" w="med" len="med"/>
+                      <a:tailEnd type="none" w="med" len="med"/>
+                    </a:lnB>
+                    <a:noFill/>
+                  </a:tcPr>
+                </a:tc>
+                <a:tc>
+                  <a:txBody>
+                    <a:bodyPr/>
+                    <a:lstStyle/>
+                    <a:p>
+                      <a:pPr>
+                        <a:buNone/>
+                      </a:pPr>
+                      <a:r>
+                        <a:rPr lang="en-GB" dirty="0"/>
+                        <a:t>0.99</a:t>
+                      </a:r>
+                    </a:p>
+                  </a:txBody>
+                  <a:tcPr anchor="ctr">
+                    <a:lnL w="12700" cap="flat" cmpd="sng" algn="ctr">
+                      <a:solidFill>
+                        <a:schemeClr val="tx1"/>
+                      </a:solidFill>
+                      <a:prstDash val="solid"/>
+                      <a:round/>
+                      <a:headEnd type="none" w="med" len="med"/>
+                      <a:tailEnd type="none" w="med" len="med"/>
+                    </a:lnL>
+                    <a:lnR w="12700" cap="flat" cmpd="sng" algn="ctr">
+                      <a:solidFill>
+                        <a:schemeClr val="tx1"/>
+                      </a:solidFill>
+                      <a:prstDash val="solid"/>
+                      <a:round/>
+                      <a:headEnd type="none" w="med" len="med"/>
+                      <a:tailEnd type="none" w="med" len="med"/>
+                    </a:lnR>
+                    <a:lnT w="12700" cap="flat" cmpd="sng" algn="ctr">
+                      <a:solidFill>
+                        <a:schemeClr val="tx1"/>
+                      </a:solidFill>
+                      <a:prstDash val="solid"/>
+                      <a:round/>
+                      <a:headEnd type="none" w="med" len="med"/>
+                      <a:tailEnd type="none" w="med" len="med"/>
+                    </a:lnT>
+                    <a:lnB w="12700" cap="flat" cmpd="sng" algn="ctr">
+                      <a:solidFill>
+                        <a:schemeClr val="tx1"/>
+                      </a:solidFill>
+                      <a:prstDash val="solid"/>
+                      <a:round/>
+                      <a:headEnd type="none" w="med" len="med"/>
+                      <a:tailEnd type="none" w="med" len="med"/>
+                    </a:lnB>
+                    <a:noFill/>
+                  </a:tcPr>
+                </a:tc>
+                <a:tc>
+                  <a:txBody>
+                    <a:bodyPr/>
+                    <a:lstStyle/>
+                    <a:p>
+                      <a:pPr>
+                        <a:buNone/>
+                      </a:pPr>
+                      <a:r>
+                        <a:rPr lang="en-GB" dirty="0"/>
+                        <a:t>8980</a:t>
+                      </a:r>
+                    </a:p>
+                  </a:txBody>
+                  <a:tcPr anchor="ctr">
+                    <a:lnL w="12700" cap="flat" cmpd="sng" algn="ctr">
+                      <a:solidFill>
+                        <a:schemeClr val="tx1"/>
+                      </a:solidFill>
+                      <a:prstDash val="solid"/>
+                      <a:round/>
+                      <a:headEnd type="none" w="med" len="med"/>
+                      <a:tailEnd type="none" w="med" len="med"/>
+                    </a:lnL>
+                    <a:lnR w="12700" cap="flat" cmpd="sng" algn="ctr">
+                      <a:solidFill>
+                        <a:schemeClr val="tx1"/>
+                      </a:solidFill>
+                      <a:prstDash val="solid"/>
+                      <a:round/>
+                      <a:headEnd type="none" w="med" len="med"/>
+                      <a:tailEnd type="none" w="med" len="med"/>
+                    </a:lnR>
+                    <a:lnT w="12700" cap="flat" cmpd="sng" algn="ctr">
+                      <a:solidFill>
+                        <a:schemeClr val="tx1"/>
+                      </a:solidFill>
+                      <a:prstDash val="solid"/>
+                      <a:round/>
+                      <a:headEnd type="none" w="med" len="med"/>
+                      <a:tailEnd type="none" w="med" len="med"/>
+                    </a:lnT>
+                    <a:lnB w="12700" cap="flat" cmpd="sng" algn="ctr">
+                      <a:solidFill>
+                        <a:schemeClr val="tx1"/>
+                      </a:solidFill>
+                      <a:prstDash val="solid"/>
+                      <a:round/>
+                      <a:headEnd type="none" w="med" len="med"/>
+                      <a:tailEnd type="none" w="med" len="med"/>
+                    </a:lnB>
+                    <a:noFill/>
+                  </a:tcPr>
+                </a:tc>
+                <a:extLst>
+                  <a:ext uri="{0D108BD9-81ED-4DB2-BD59-A6C34878D82A}">
+                    <a16:rowId xmlns:a16="http://schemas.microsoft.com/office/drawing/2014/main" val="3625560076"/>
+                  </a:ext>
+                </a:extLst>
+              </a:tr>
+              <a:tr h="334707">
+                <a:tc>
+                  <a:txBody>
+                    <a:bodyPr/>
+                    <a:lstStyle/>
+                    <a:p>
+                      <a:pPr>
+                        <a:buNone/>
+                      </a:pPr>
+                      <a:r>
+                        <a:rPr lang="en-GB" b="1" dirty="0"/>
+                        <a:t>Weighted </a:t>
+                      </a:r>
+                      <a:r>
+                        <a:rPr lang="en-GB" b="1" dirty="0" err="1"/>
+                        <a:t>Avg</a:t>
+                      </a:r>
+                      <a:endParaRPr lang="en-GB" dirty="0"/>
+                    </a:p>
+                  </a:txBody>
+                  <a:tcPr anchor="ctr">
+                    <a:lnL w="12700" cap="flat" cmpd="sng" algn="ctr">
+                      <a:solidFill>
+                        <a:schemeClr val="tx1"/>
+                      </a:solidFill>
+                      <a:prstDash val="solid"/>
+                      <a:round/>
+                      <a:headEnd type="none" w="med" len="med"/>
+                      <a:tailEnd type="none" w="med" len="med"/>
+                    </a:lnL>
+                    <a:lnR w="12700" cap="flat" cmpd="sng" algn="ctr">
+                      <a:solidFill>
+                        <a:schemeClr val="tx1"/>
+                      </a:solidFill>
+                      <a:prstDash val="solid"/>
+                      <a:round/>
+                      <a:headEnd type="none" w="med" len="med"/>
+                      <a:tailEnd type="none" w="med" len="med"/>
+                    </a:lnR>
+                    <a:lnT w="12700" cap="flat" cmpd="sng" algn="ctr">
+                      <a:solidFill>
+                        <a:schemeClr val="tx1"/>
+                      </a:solidFill>
+                      <a:prstDash val="solid"/>
+                      <a:round/>
+                      <a:headEnd type="none" w="med" len="med"/>
+                      <a:tailEnd type="none" w="med" len="med"/>
+                    </a:lnT>
+                    <a:lnB w="12700" cap="flat" cmpd="sng" algn="ctr">
+                      <a:solidFill>
+                        <a:schemeClr val="tx1"/>
+                      </a:solidFill>
+                      <a:prstDash val="solid"/>
+                      <a:round/>
+                      <a:headEnd type="none" w="med" len="med"/>
+                      <a:tailEnd type="none" w="med" len="med"/>
+                    </a:lnB>
+                    <a:noFill/>
+                  </a:tcPr>
+                </a:tc>
+                <a:tc>
+                  <a:txBody>
+                    <a:bodyPr/>
+                    <a:lstStyle/>
+                    <a:p>
+                      <a:pPr>
+                        <a:buNone/>
+                      </a:pPr>
+                      <a:r>
+                        <a:rPr lang="en-GB" dirty="0"/>
+                        <a:t>0.99</a:t>
+                      </a:r>
+                    </a:p>
+                  </a:txBody>
+                  <a:tcPr anchor="ctr">
+                    <a:lnL w="12700" cap="flat" cmpd="sng" algn="ctr">
+                      <a:solidFill>
+                        <a:schemeClr val="tx1"/>
+                      </a:solidFill>
+                      <a:prstDash val="solid"/>
+                      <a:round/>
+                      <a:headEnd type="none" w="med" len="med"/>
+                      <a:tailEnd type="none" w="med" len="med"/>
+                    </a:lnL>
+                    <a:lnR w="12700" cap="flat" cmpd="sng" algn="ctr">
+                      <a:solidFill>
+                        <a:schemeClr val="tx1"/>
+                      </a:solidFill>
+                      <a:prstDash val="solid"/>
+                      <a:round/>
+                      <a:headEnd type="none" w="med" len="med"/>
+                      <a:tailEnd type="none" w="med" len="med"/>
+                    </a:lnR>
+                    <a:lnT w="12700" cap="flat" cmpd="sng" algn="ctr">
+                      <a:solidFill>
+                        <a:schemeClr val="tx1"/>
+                      </a:solidFill>
+                      <a:prstDash val="solid"/>
+                      <a:round/>
+                      <a:headEnd type="none" w="med" len="med"/>
+                      <a:tailEnd type="none" w="med" len="med"/>
+                    </a:lnT>
+                    <a:lnB w="12700" cap="flat" cmpd="sng" algn="ctr">
+                      <a:solidFill>
+                        <a:schemeClr val="tx1"/>
+                      </a:solidFill>
+                      <a:prstDash val="solid"/>
+                      <a:round/>
+                      <a:headEnd type="none" w="med" len="med"/>
+                      <a:tailEnd type="none" w="med" len="med"/>
+                    </a:lnB>
+                    <a:noFill/>
+                  </a:tcPr>
+                </a:tc>
+                <a:tc>
+                  <a:txBody>
+                    <a:bodyPr/>
+                    <a:lstStyle/>
+                    <a:p>
+                      <a:pPr>
+                        <a:buNone/>
+                      </a:pPr>
+                      <a:r>
+                        <a:rPr lang="en-GB" dirty="0"/>
+                        <a:t>0.99</a:t>
+                      </a:r>
+                    </a:p>
+                  </a:txBody>
+                  <a:tcPr anchor="ctr">
+                    <a:lnL w="12700" cap="flat" cmpd="sng" algn="ctr">
+                      <a:solidFill>
+                        <a:schemeClr val="tx1"/>
+                      </a:solidFill>
+                      <a:prstDash val="solid"/>
+                      <a:round/>
+                      <a:headEnd type="none" w="med" len="med"/>
+                      <a:tailEnd type="none" w="med" len="med"/>
+                    </a:lnL>
+                    <a:lnR w="12700" cap="flat" cmpd="sng" algn="ctr">
+                      <a:solidFill>
+                        <a:schemeClr val="tx1"/>
+                      </a:solidFill>
+                      <a:prstDash val="solid"/>
+                      <a:round/>
+                      <a:headEnd type="none" w="med" len="med"/>
+                      <a:tailEnd type="none" w="med" len="med"/>
+                    </a:lnR>
+                    <a:lnT w="12700" cap="flat" cmpd="sng" algn="ctr">
+                      <a:solidFill>
+                        <a:schemeClr val="tx1"/>
+                      </a:solidFill>
+                      <a:prstDash val="solid"/>
+                      <a:round/>
+                      <a:headEnd type="none" w="med" len="med"/>
+                      <a:tailEnd type="none" w="med" len="med"/>
+                    </a:lnT>
+                    <a:lnB w="12700" cap="flat" cmpd="sng" algn="ctr">
+                      <a:solidFill>
+                        <a:schemeClr val="tx1"/>
+                      </a:solidFill>
+                      <a:prstDash val="solid"/>
+                      <a:round/>
+                      <a:headEnd type="none" w="med" len="med"/>
+                      <a:tailEnd type="none" w="med" len="med"/>
+                    </a:lnB>
+                    <a:noFill/>
+                  </a:tcPr>
+                </a:tc>
+                <a:tc>
+                  <a:txBody>
+                    <a:bodyPr/>
+                    <a:lstStyle/>
+                    <a:p>
+                      <a:pPr>
+                        <a:buNone/>
+                      </a:pPr>
+                      <a:r>
+                        <a:rPr lang="en-GB" dirty="0"/>
+                        <a:t>0.99</a:t>
+                      </a:r>
+                    </a:p>
+                  </a:txBody>
+                  <a:tcPr anchor="ctr">
+                    <a:lnL w="12700" cap="flat" cmpd="sng" algn="ctr">
+                      <a:solidFill>
+                        <a:schemeClr val="tx1"/>
+                      </a:solidFill>
+                      <a:prstDash val="solid"/>
+                      <a:round/>
+                      <a:headEnd type="none" w="med" len="med"/>
+                      <a:tailEnd type="none" w="med" len="med"/>
+                    </a:lnL>
+                    <a:lnR w="12700" cap="flat" cmpd="sng" algn="ctr">
+                      <a:solidFill>
+                        <a:schemeClr val="tx1"/>
+                      </a:solidFill>
+                      <a:prstDash val="solid"/>
+                      <a:round/>
+                      <a:headEnd type="none" w="med" len="med"/>
+                      <a:tailEnd type="none" w="med" len="med"/>
+                    </a:lnR>
+                    <a:lnT w="12700" cap="flat" cmpd="sng" algn="ctr">
+                      <a:solidFill>
+                        <a:schemeClr val="tx1"/>
+                      </a:solidFill>
+                      <a:prstDash val="solid"/>
+                      <a:round/>
+                      <a:headEnd type="none" w="med" len="med"/>
+                      <a:tailEnd type="none" w="med" len="med"/>
+                    </a:lnT>
+                    <a:lnB w="12700" cap="flat" cmpd="sng" algn="ctr">
+                      <a:solidFill>
+                        <a:schemeClr val="tx1"/>
+                      </a:solidFill>
+                      <a:prstDash val="solid"/>
+                      <a:round/>
+                      <a:headEnd type="none" w="med" len="med"/>
+                      <a:tailEnd type="none" w="med" len="med"/>
+                    </a:lnB>
+                    <a:noFill/>
+                  </a:tcPr>
+                </a:tc>
+                <a:tc>
+                  <a:txBody>
+                    <a:bodyPr/>
+                    <a:lstStyle/>
+                    <a:p>
+                      <a:pPr>
+                        <a:buNone/>
+                      </a:pPr>
+                      <a:r>
+                        <a:rPr lang="en-GB" dirty="0"/>
+                        <a:t>8980</a:t>
+                      </a:r>
+                    </a:p>
+                  </a:txBody>
+                  <a:tcPr anchor="ctr">
+                    <a:lnL w="12700" cap="flat" cmpd="sng" algn="ctr">
+                      <a:solidFill>
+                        <a:schemeClr val="tx1"/>
+                      </a:solidFill>
+                      <a:prstDash val="solid"/>
+                      <a:round/>
+                      <a:headEnd type="none" w="med" len="med"/>
+                      <a:tailEnd type="none" w="med" len="med"/>
+                    </a:lnL>
+                    <a:lnR w="12700" cap="flat" cmpd="sng" algn="ctr">
+                      <a:solidFill>
+                        <a:schemeClr val="tx1"/>
+                      </a:solidFill>
+                      <a:prstDash val="solid"/>
+                      <a:round/>
+                      <a:headEnd type="none" w="med" len="med"/>
+                      <a:tailEnd type="none" w="med" len="med"/>
+                    </a:lnR>
+                    <a:lnT w="12700" cap="flat" cmpd="sng" algn="ctr">
+                      <a:solidFill>
+                        <a:schemeClr val="tx1"/>
+                      </a:solidFill>
+                      <a:prstDash val="solid"/>
+                      <a:round/>
+                      <a:headEnd type="none" w="med" len="med"/>
+                      <a:tailEnd type="none" w="med" len="med"/>
+                    </a:lnT>
+                    <a:lnB w="12700" cap="flat" cmpd="sng" algn="ctr">
+                      <a:solidFill>
+                        <a:schemeClr val="tx1"/>
+                      </a:solidFill>
+                      <a:prstDash val="solid"/>
+                      <a:round/>
+                      <a:headEnd type="none" w="med" len="med"/>
+                      <a:tailEnd type="none" w="med" len="med"/>
+                    </a:lnB>
+                    <a:noFill/>
+                  </a:tcPr>
+                </a:tc>
+                <a:extLst>
+                  <a:ext uri="{0D108BD9-81ED-4DB2-BD59-A6C34878D82A}">
+                    <a16:rowId xmlns:a16="http://schemas.microsoft.com/office/drawing/2014/main" val="4085293771"/>
+                  </a:ext>
+                </a:extLst>
+              </a:tr>
+            </a:tbl>
+          </a:graphicData>
+        </a:graphic>
+      </p:graphicFrame>
+    </p:spTree>
+    <p:extLst>
+      <p:ext uri="{BB962C8B-B14F-4D97-AF65-F5344CB8AC3E}">
+        <p14:creationId xmlns:p14="http://schemas.microsoft.com/office/powerpoint/2010/main" val="145002764"/>
+      </p:ext>
+    </p:extLst>
+  </p:cSld>
+  <p:clrMapOvr>
+    <a:masterClrMapping/>
+  </p:clrMapOvr>
+</p:sld>
+</file>
+
+<file path=ppt/slides/slide15.xml><?xml version="1.0" encoding="utf-8"?>
+<p:sld xmlns:a="http://schemas.openxmlformats.org/drawingml/2006/main" xmlns:r="http://schemas.openxmlformats.org/officeDocument/2006/relationships" xmlns:p="http://schemas.openxmlformats.org/presentationml/2006/main">
+  <p:cSld>
+    <p:spTree>
+      <p:nvGrpSpPr>
+        <p:cNvPr id="1" name="">
+          <a:extLst>
+            <a:ext uri="{FF2B5EF4-FFF2-40B4-BE49-F238E27FC236}">
+              <a16:creationId xmlns:a16="http://schemas.microsoft.com/office/drawing/2014/main" id="{290DD34F-17FD-16E0-77D1-695A8D4978B9}"/>
+            </a:ext>
+          </a:extLst>
+        </p:cNvPr>
+        <p:cNvGrpSpPr/>
+        <p:nvPr/>
+      </p:nvGrpSpPr>
+      <p:grpSpPr>
+        <a:xfrm>
+          <a:off x="0" y="0"/>
+          <a:ext cx="0" cy="0"/>
+          <a:chOff x="0" y="0"/>
+          <a:chExt cx="0" cy="0"/>
+        </a:xfrm>
+      </p:grpSpPr>
+      <p:sp>
+        <p:nvSpPr>
+          <p:cNvPr id="4" name="Título 1">
+            <a:extLst>
+              <a:ext uri="{FF2B5EF4-FFF2-40B4-BE49-F238E27FC236}">
+                <a16:creationId xmlns:a16="http://schemas.microsoft.com/office/drawing/2014/main" id="{E991D3E0-E845-AB71-8EC1-7AD33C038EE7}"/>
+              </a:ext>
+            </a:extLst>
+          </p:cNvPr>
+          <p:cNvSpPr>
+            <a:spLocks noGrp="1"/>
+          </p:cNvSpPr>
+          <p:nvPr>
+            <p:ph type="title"/>
+          </p:nvPr>
+        </p:nvSpPr>
+        <p:spPr>
+          <a:xfrm>
+            <a:off x="110612" y="355293"/>
+            <a:ext cx="8590936" cy="1325563"/>
+          </a:xfrm>
+        </p:spPr>
+        <p:txBody>
+          <a:bodyPr/>
+          <a:lstStyle/>
+          <a:p>
+            <a:r>
+              <a:rPr lang="en-US" dirty="0"/>
+              <a:t>SVM results</a:t>
+            </a:r>
+            <a:endParaRPr lang="en-GB" dirty="0"/>
+          </a:p>
+        </p:txBody>
+      </p:sp>
+      <p:sp>
+        <p:nvSpPr>
+          <p:cNvPr id="6" name="CuadroTexto 5">
+            <a:extLst>
+              <a:ext uri="{FF2B5EF4-FFF2-40B4-BE49-F238E27FC236}">
+                <a16:creationId xmlns:a16="http://schemas.microsoft.com/office/drawing/2014/main" id="{938257A2-2EE3-563E-6C19-34AE142DE275}"/>
+              </a:ext>
+            </a:extLst>
+          </p:cNvPr>
+          <p:cNvSpPr txBox="1"/>
+          <p:nvPr/>
+        </p:nvSpPr>
+        <p:spPr>
+          <a:xfrm>
+            <a:off x="688260" y="1577759"/>
+            <a:ext cx="2861185" cy="523220"/>
+          </a:xfrm>
+          <a:prstGeom prst="rect">
+            <a:avLst/>
+          </a:prstGeom>
+          <a:noFill/>
+        </p:spPr>
+        <p:txBody>
+          <a:bodyPr wrap="square" rtlCol="0">
+            <a:spAutoFit/>
+          </a:bodyPr>
+          <a:lstStyle/>
+          <a:p>
+            <a:r>
+              <a:rPr lang="en-US" sz="2800" dirty="0"/>
+              <a:t>SVM with tuning</a:t>
+            </a:r>
+            <a:endParaRPr lang="en-GB" sz="2800" dirty="0"/>
+          </a:p>
+        </p:txBody>
+      </p:sp>
+      <p:graphicFrame>
+        <p:nvGraphicFramePr>
+          <p:cNvPr id="8" name="Tabla 7">
+            <a:extLst>
+              <a:ext uri="{FF2B5EF4-FFF2-40B4-BE49-F238E27FC236}">
+                <a16:creationId xmlns:a16="http://schemas.microsoft.com/office/drawing/2014/main" id="{E3C27232-EBDA-0439-D729-EBD428DBFBFC}"/>
+              </a:ext>
+            </a:extLst>
+          </p:cNvPr>
+          <p:cNvGraphicFramePr>
+            <a:graphicFrameLocks noGrp="1"/>
+          </p:cNvGraphicFramePr>
+          <p:nvPr>
+            <p:extLst>
+              <p:ext uri="{D42A27DB-BD31-4B8C-83A1-F6EECF244321}">
+                <p14:modId xmlns:p14="http://schemas.microsoft.com/office/powerpoint/2010/main" val="1097060912"/>
+              </p:ext>
+            </p:extLst>
+          </p:nvPr>
+        </p:nvGraphicFramePr>
+        <p:xfrm>
+          <a:off x="2814480" y="3214346"/>
+          <a:ext cx="5641260" cy="2468880"/>
+        </p:xfrm>
+        <a:graphic>
+          <a:graphicData uri="http://schemas.openxmlformats.org/drawingml/2006/table">
+            <a:tbl>
+              <a:tblPr/>
+              <a:tblGrid>
+                <a:gridCol w="1256072">
+                  <a:extLst>
+                    <a:ext uri="{9D8B030D-6E8A-4147-A177-3AD203B41FA5}">
+                      <a16:colId xmlns:a16="http://schemas.microsoft.com/office/drawing/2014/main" val="2529616538"/>
+                    </a:ext>
+                  </a:extLst>
+                </a:gridCol>
+                <a:gridCol w="1101213">
+                  <a:extLst>
+                    <a:ext uri="{9D8B030D-6E8A-4147-A177-3AD203B41FA5}">
+                      <a16:colId xmlns:a16="http://schemas.microsoft.com/office/drawing/2014/main" val="300941870"/>
+                    </a:ext>
+                  </a:extLst>
+                </a:gridCol>
+                <a:gridCol w="1027471">
+                  <a:extLst>
+                    <a:ext uri="{9D8B030D-6E8A-4147-A177-3AD203B41FA5}">
+                      <a16:colId xmlns:a16="http://schemas.microsoft.com/office/drawing/2014/main" val="1070201705"/>
+                    </a:ext>
+                  </a:extLst>
+                </a:gridCol>
+                <a:gridCol w="1128252">
+                  <a:extLst>
+                    <a:ext uri="{9D8B030D-6E8A-4147-A177-3AD203B41FA5}">
+                      <a16:colId xmlns:a16="http://schemas.microsoft.com/office/drawing/2014/main" val="417569215"/>
+                    </a:ext>
+                  </a:extLst>
+                </a:gridCol>
+                <a:gridCol w="1128252">
+                  <a:extLst>
+                    <a:ext uri="{9D8B030D-6E8A-4147-A177-3AD203B41FA5}">
+                      <a16:colId xmlns:a16="http://schemas.microsoft.com/office/drawing/2014/main" val="2682234863"/>
+                    </a:ext>
+                  </a:extLst>
+                </a:gridCol>
+              </a:tblGrid>
+              <a:tr h="334707">
+                <a:tc>
+                  <a:txBody>
+                    <a:bodyPr/>
+                    <a:lstStyle/>
+                    <a:p>
+                      <a:pPr>
+                        <a:buNone/>
+                      </a:pPr>
+                      <a:r>
+                        <a:rPr lang="en-GB" dirty="0"/>
+                        <a:t>Class</a:t>
+                      </a:r>
+                    </a:p>
+                  </a:txBody>
+                  <a:tcPr anchor="ctr">
+                    <a:lnL w="12700" cap="flat" cmpd="sng" algn="ctr">
+                      <a:solidFill>
+                        <a:schemeClr val="tx1"/>
+                      </a:solidFill>
+                      <a:prstDash val="solid"/>
+                      <a:round/>
+                      <a:headEnd type="none" w="med" len="med"/>
+                      <a:tailEnd type="none" w="med" len="med"/>
+                    </a:lnL>
+                    <a:lnR w="12700" cap="flat" cmpd="sng" algn="ctr">
+                      <a:solidFill>
+                        <a:schemeClr val="tx1"/>
+                      </a:solidFill>
+                      <a:prstDash val="solid"/>
+                      <a:round/>
+                      <a:headEnd type="none" w="med" len="med"/>
+                      <a:tailEnd type="none" w="med" len="med"/>
+                    </a:lnR>
+                    <a:lnT w="12700" cap="flat" cmpd="sng" algn="ctr">
+                      <a:solidFill>
+                        <a:schemeClr val="tx1"/>
+                      </a:solidFill>
+                      <a:prstDash val="solid"/>
+                      <a:round/>
+                      <a:headEnd type="none" w="med" len="med"/>
+                      <a:tailEnd type="none" w="med" len="med"/>
+                    </a:lnT>
+                    <a:lnB w="12700" cap="flat" cmpd="sng" algn="ctr">
+                      <a:solidFill>
+                        <a:schemeClr val="tx1"/>
+                      </a:solidFill>
+                      <a:prstDash val="solid"/>
+                      <a:round/>
+                      <a:headEnd type="none" w="med" len="med"/>
+                      <a:tailEnd type="none" w="med" len="med"/>
+                    </a:lnB>
+                    <a:noFill/>
+                  </a:tcPr>
+                </a:tc>
+                <a:tc>
+                  <a:txBody>
+                    <a:bodyPr/>
+                    <a:lstStyle/>
+                    <a:p>
+                      <a:pPr>
+                        <a:buNone/>
+                      </a:pPr>
+                      <a:r>
+                        <a:rPr lang="en-GB" dirty="0"/>
+                        <a:t>Precision</a:t>
+                      </a:r>
                     </a:p>
                   </a:txBody>
                   <a:tcPr anchor="ctr">
@@ -5106,7 +5863,61 @@
                       </a:pPr>
                       <a:r>
                         <a:rPr lang="en-GB"/>
-                        <a:t>1.00</a:t>
+                        <a:t>Recall</a:t>
+                      </a:r>
+                    </a:p>
+                  </a:txBody>
+                  <a:tcPr anchor="ctr">
+                    <a:lnL w="12700" cap="flat" cmpd="sng" algn="ctr">
+                      <a:solidFill>
+                        <a:schemeClr val="tx1"/>
+                      </a:solidFill>
+                      <a:prstDash val="solid"/>
+                      <a:round/>
+                      <a:headEnd type="none" w="med" len="med"/>
+                      <a:tailEnd type="none" w="med" len="med"/>
+                    </a:lnL>
+                    <a:lnR w="12700" cap="flat" cmpd="sng" algn="ctr">
+                      <a:solidFill>
+                        <a:schemeClr val="tx1"/>
+                      </a:solidFill>
+                      <a:prstDash val="solid"/>
+                      <a:round/>
+                      <a:headEnd type="none" w="med" len="med"/>
+                      <a:tailEnd type="none" w="med" len="med"/>
+                    </a:lnR>
+                    <a:lnT w="12700" cap="flat" cmpd="sng" algn="ctr">
+                      <a:solidFill>
+                        <a:schemeClr val="tx1"/>
+                      </a:solidFill>
+                      <a:prstDash val="solid"/>
+                      <a:round/>
+                      <a:headEnd type="none" w="med" len="med"/>
+                      <a:tailEnd type="none" w="med" len="med"/>
+                    </a:lnT>
+                    <a:lnB w="12700" cap="flat" cmpd="sng" algn="ctr">
+                      <a:solidFill>
+                        <a:schemeClr val="tx1"/>
+                      </a:solidFill>
+                      <a:prstDash val="solid"/>
+                      <a:round/>
+                      <a:headEnd type="none" w="med" len="med"/>
+                      <a:tailEnd type="none" w="med" len="med"/>
+                    </a:lnB>
+                    <a:noFill/>
+                  </a:tcPr>
+                </a:tc>
+                <a:tc>
+                  <a:txBody>
+                    <a:bodyPr/>
+                    <a:lstStyle/>
+                    <a:p>
+                      <a:pPr>
+                        <a:buNone/>
+                      </a:pPr>
+                      <a:r>
+                        <a:rPr lang="en-GB" dirty="0"/>
+                        <a:t>F1-score</a:t>
                       </a:r>
                     </a:p>
                   </a:txBody>
@@ -5160,7 +5971,68 @@
                       </a:pPr>
                       <a:r>
                         <a:rPr lang="en-GB"/>
-                        <a:t>1.00</a:t>
+                        <a:t>Support</a:t>
+                      </a:r>
+                    </a:p>
+                  </a:txBody>
+                  <a:tcPr anchor="ctr">
+                    <a:lnL w="12700" cap="flat" cmpd="sng" algn="ctr">
+                      <a:solidFill>
+                        <a:schemeClr val="tx1"/>
+                      </a:solidFill>
+                      <a:prstDash val="solid"/>
+                      <a:round/>
+                      <a:headEnd type="none" w="med" len="med"/>
+                      <a:tailEnd type="none" w="med" len="med"/>
+                    </a:lnL>
+                    <a:lnR w="12700" cap="flat" cmpd="sng" algn="ctr">
+                      <a:solidFill>
+                        <a:schemeClr val="tx1"/>
+                      </a:solidFill>
+                      <a:prstDash val="solid"/>
+                      <a:round/>
+                      <a:headEnd type="none" w="med" len="med"/>
+                      <a:tailEnd type="none" w="med" len="med"/>
+                    </a:lnR>
+                    <a:lnT w="12700" cap="flat" cmpd="sng" algn="ctr">
+                      <a:solidFill>
+                        <a:schemeClr val="tx1"/>
+                      </a:solidFill>
+                      <a:prstDash val="solid"/>
+                      <a:round/>
+                      <a:headEnd type="none" w="med" len="med"/>
+                      <a:tailEnd type="none" w="med" len="med"/>
+                    </a:lnT>
+                    <a:lnB w="12700" cap="flat" cmpd="sng" algn="ctr">
+                      <a:solidFill>
+                        <a:schemeClr val="tx1"/>
+                      </a:solidFill>
+                      <a:prstDash val="solid"/>
+                      <a:round/>
+                      <a:headEnd type="none" w="med" len="med"/>
+                      <a:tailEnd type="none" w="med" len="med"/>
+                    </a:lnB>
+                    <a:noFill/>
+                  </a:tcPr>
+                </a:tc>
+                <a:extLst>
+                  <a:ext uri="{0D108BD9-81ED-4DB2-BD59-A6C34878D82A}">
+                    <a16:rowId xmlns:a16="http://schemas.microsoft.com/office/drawing/2014/main" val="618331434"/>
+                  </a:ext>
+                </a:extLst>
+              </a:tr>
+              <a:tr h="334707">
+                <a:tc>
+                  <a:txBody>
+                    <a:bodyPr/>
+                    <a:lstStyle/>
+                    <a:p>
+                      <a:pPr>
+                        <a:buNone/>
+                      </a:pPr>
+                      <a:r>
+                        <a:rPr lang="en-GB" dirty="0"/>
+                        <a:t>Real</a:t>
                       </a:r>
                     </a:p>
                   </a:txBody>
@@ -5268,6 +6140,951 @@
                       </a:pPr>
                       <a:r>
                         <a:rPr lang="en-GB" dirty="0"/>
+                        <a:t>1.00</a:t>
+                      </a:r>
+                    </a:p>
+                  </a:txBody>
+                  <a:tcPr anchor="ctr">
+                    <a:lnL w="12700" cap="flat" cmpd="sng" algn="ctr">
+                      <a:solidFill>
+                        <a:schemeClr val="tx1"/>
+                      </a:solidFill>
+                      <a:prstDash val="solid"/>
+                      <a:round/>
+                      <a:headEnd type="none" w="med" len="med"/>
+                      <a:tailEnd type="none" w="med" len="med"/>
+                    </a:lnL>
+                    <a:lnR w="12700" cap="flat" cmpd="sng" algn="ctr">
+                      <a:solidFill>
+                        <a:schemeClr val="tx1"/>
+                      </a:solidFill>
+                      <a:prstDash val="solid"/>
+                      <a:round/>
+                      <a:headEnd type="none" w="med" len="med"/>
+                      <a:tailEnd type="none" w="med" len="med"/>
+                    </a:lnR>
+                    <a:lnT w="12700" cap="flat" cmpd="sng" algn="ctr">
+                      <a:solidFill>
+                        <a:schemeClr val="tx1"/>
+                      </a:solidFill>
+                      <a:prstDash val="solid"/>
+                      <a:round/>
+                      <a:headEnd type="none" w="med" len="med"/>
+                      <a:tailEnd type="none" w="med" len="med"/>
+                    </a:lnT>
+                    <a:lnB w="12700" cap="flat" cmpd="sng" algn="ctr">
+                      <a:solidFill>
+                        <a:schemeClr val="tx1"/>
+                      </a:solidFill>
+                      <a:prstDash val="solid"/>
+                      <a:round/>
+                      <a:headEnd type="none" w="med" len="med"/>
+                      <a:tailEnd type="none" w="med" len="med"/>
+                    </a:lnB>
+                    <a:noFill/>
+                  </a:tcPr>
+                </a:tc>
+                <a:tc>
+                  <a:txBody>
+                    <a:bodyPr/>
+                    <a:lstStyle/>
+                    <a:p>
+                      <a:pPr>
+                        <a:buNone/>
+                      </a:pPr>
+                      <a:r>
+                        <a:rPr lang="en-GB" dirty="0"/>
+                        <a:t>1.00</a:t>
+                      </a:r>
+                    </a:p>
+                  </a:txBody>
+                  <a:tcPr anchor="ctr">
+                    <a:lnL w="12700" cap="flat" cmpd="sng" algn="ctr">
+                      <a:solidFill>
+                        <a:schemeClr val="tx1"/>
+                      </a:solidFill>
+                      <a:prstDash val="solid"/>
+                      <a:round/>
+                      <a:headEnd type="none" w="med" len="med"/>
+                      <a:tailEnd type="none" w="med" len="med"/>
+                    </a:lnL>
+                    <a:lnR w="12700" cap="flat" cmpd="sng" algn="ctr">
+                      <a:solidFill>
+                        <a:schemeClr val="tx1"/>
+                      </a:solidFill>
+                      <a:prstDash val="solid"/>
+                      <a:round/>
+                      <a:headEnd type="none" w="med" len="med"/>
+                      <a:tailEnd type="none" w="med" len="med"/>
+                    </a:lnR>
+                    <a:lnT w="12700" cap="flat" cmpd="sng" algn="ctr">
+                      <a:solidFill>
+                        <a:schemeClr val="tx1"/>
+                      </a:solidFill>
+                      <a:prstDash val="solid"/>
+                      <a:round/>
+                      <a:headEnd type="none" w="med" len="med"/>
+                      <a:tailEnd type="none" w="med" len="med"/>
+                    </a:lnT>
+                    <a:lnB w="12700" cap="flat" cmpd="sng" algn="ctr">
+                      <a:solidFill>
+                        <a:schemeClr val="tx1"/>
+                      </a:solidFill>
+                      <a:prstDash val="solid"/>
+                      <a:round/>
+                      <a:headEnd type="none" w="med" len="med"/>
+                      <a:tailEnd type="none" w="med" len="med"/>
+                    </a:lnB>
+                    <a:noFill/>
+                  </a:tcPr>
+                </a:tc>
+                <a:tc>
+                  <a:txBody>
+                    <a:bodyPr/>
+                    <a:lstStyle/>
+                    <a:p>
+                      <a:pPr>
+                        <a:buNone/>
+                      </a:pPr>
+                      <a:r>
+                        <a:rPr lang="en-GB" dirty="0"/>
+                        <a:t>4284</a:t>
+                      </a:r>
+                    </a:p>
+                  </a:txBody>
+                  <a:tcPr anchor="ctr">
+                    <a:lnL w="12700" cap="flat" cmpd="sng" algn="ctr">
+                      <a:solidFill>
+                        <a:schemeClr val="tx1"/>
+                      </a:solidFill>
+                      <a:prstDash val="solid"/>
+                      <a:round/>
+                      <a:headEnd type="none" w="med" len="med"/>
+                      <a:tailEnd type="none" w="med" len="med"/>
+                    </a:lnL>
+                    <a:lnR w="12700" cap="flat" cmpd="sng" algn="ctr">
+                      <a:solidFill>
+                        <a:schemeClr val="tx1"/>
+                      </a:solidFill>
+                      <a:prstDash val="solid"/>
+                      <a:round/>
+                      <a:headEnd type="none" w="med" len="med"/>
+                      <a:tailEnd type="none" w="med" len="med"/>
+                    </a:lnR>
+                    <a:lnT w="12700" cap="flat" cmpd="sng" algn="ctr">
+                      <a:solidFill>
+                        <a:schemeClr val="tx1"/>
+                      </a:solidFill>
+                      <a:prstDash val="solid"/>
+                      <a:round/>
+                      <a:headEnd type="none" w="med" len="med"/>
+                      <a:tailEnd type="none" w="med" len="med"/>
+                    </a:lnT>
+                    <a:lnB w="12700" cap="flat" cmpd="sng" algn="ctr">
+                      <a:solidFill>
+                        <a:schemeClr val="tx1"/>
+                      </a:solidFill>
+                      <a:prstDash val="solid"/>
+                      <a:round/>
+                      <a:headEnd type="none" w="med" len="med"/>
+                      <a:tailEnd type="none" w="med" len="med"/>
+                    </a:lnB>
+                    <a:noFill/>
+                  </a:tcPr>
+                </a:tc>
+                <a:extLst>
+                  <a:ext uri="{0D108BD9-81ED-4DB2-BD59-A6C34878D82A}">
+                    <a16:rowId xmlns:a16="http://schemas.microsoft.com/office/drawing/2014/main" val="1867091066"/>
+                  </a:ext>
+                </a:extLst>
+              </a:tr>
+              <a:tr h="334707">
+                <a:tc>
+                  <a:txBody>
+                    <a:bodyPr/>
+                    <a:lstStyle/>
+                    <a:p>
+                      <a:pPr>
+                        <a:buNone/>
+                      </a:pPr>
+                      <a:r>
+                        <a:rPr lang="en-GB" dirty="0"/>
+                        <a:t>Fake</a:t>
+                      </a:r>
+                    </a:p>
+                  </a:txBody>
+                  <a:tcPr anchor="ctr">
+                    <a:lnL w="12700" cap="flat" cmpd="sng" algn="ctr">
+                      <a:solidFill>
+                        <a:schemeClr val="tx1"/>
+                      </a:solidFill>
+                      <a:prstDash val="solid"/>
+                      <a:round/>
+                      <a:headEnd type="none" w="med" len="med"/>
+                      <a:tailEnd type="none" w="med" len="med"/>
+                    </a:lnL>
+                    <a:lnR w="12700" cap="flat" cmpd="sng" algn="ctr">
+                      <a:solidFill>
+                        <a:schemeClr val="tx1"/>
+                      </a:solidFill>
+                      <a:prstDash val="solid"/>
+                      <a:round/>
+                      <a:headEnd type="none" w="med" len="med"/>
+                      <a:tailEnd type="none" w="med" len="med"/>
+                    </a:lnR>
+                    <a:lnT w="12700" cap="flat" cmpd="sng" algn="ctr">
+                      <a:solidFill>
+                        <a:schemeClr val="tx1"/>
+                      </a:solidFill>
+                      <a:prstDash val="solid"/>
+                      <a:round/>
+                      <a:headEnd type="none" w="med" len="med"/>
+                      <a:tailEnd type="none" w="med" len="med"/>
+                    </a:lnT>
+                    <a:lnB w="12700" cap="flat" cmpd="sng" algn="ctr">
+                      <a:solidFill>
+                        <a:schemeClr val="tx1"/>
+                      </a:solidFill>
+                      <a:prstDash val="solid"/>
+                      <a:round/>
+                      <a:headEnd type="none" w="med" len="med"/>
+                      <a:tailEnd type="none" w="med" len="med"/>
+                    </a:lnB>
+                    <a:noFill/>
+                  </a:tcPr>
+                </a:tc>
+                <a:tc>
+                  <a:txBody>
+                    <a:bodyPr/>
+                    <a:lstStyle/>
+                    <a:p>
+                      <a:pPr>
+                        <a:buNone/>
+                      </a:pPr>
+                      <a:r>
+                        <a:rPr lang="en-GB" dirty="0"/>
+                        <a:t>1.00</a:t>
+                      </a:r>
+                    </a:p>
+                  </a:txBody>
+                  <a:tcPr anchor="ctr">
+                    <a:lnL w="12700" cap="flat" cmpd="sng" algn="ctr">
+                      <a:solidFill>
+                        <a:schemeClr val="tx1"/>
+                      </a:solidFill>
+                      <a:prstDash val="solid"/>
+                      <a:round/>
+                      <a:headEnd type="none" w="med" len="med"/>
+                      <a:tailEnd type="none" w="med" len="med"/>
+                    </a:lnL>
+                    <a:lnR w="12700" cap="flat" cmpd="sng" algn="ctr">
+                      <a:solidFill>
+                        <a:schemeClr val="tx1"/>
+                      </a:solidFill>
+                      <a:prstDash val="solid"/>
+                      <a:round/>
+                      <a:headEnd type="none" w="med" len="med"/>
+                      <a:tailEnd type="none" w="med" len="med"/>
+                    </a:lnR>
+                    <a:lnT w="12700" cap="flat" cmpd="sng" algn="ctr">
+                      <a:solidFill>
+                        <a:schemeClr val="tx1"/>
+                      </a:solidFill>
+                      <a:prstDash val="solid"/>
+                      <a:round/>
+                      <a:headEnd type="none" w="med" len="med"/>
+                      <a:tailEnd type="none" w="med" len="med"/>
+                    </a:lnT>
+                    <a:lnB w="12700" cap="flat" cmpd="sng" algn="ctr">
+                      <a:solidFill>
+                        <a:schemeClr val="tx1"/>
+                      </a:solidFill>
+                      <a:prstDash val="solid"/>
+                      <a:round/>
+                      <a:headEnd type="none" w="med" len="med"/>
+                      <a:tailEnd type="none" w="med" len="med"/>
+                    </a:lnB>
+                    <a:noFill/>
+                  </a:tcPr>
+                </a:tc>
+                <a:tc>
+                  <a:txBody>
+                    <a:bodyPr/>
+                    <a:lstStyle/>
+                    <a:p>
+                      <a:pPr>
+                        <a:buNone/>
+                      </a:pPr>
+                      <a:r>
+                        <a:rPr lang="en-GB" dirty="0"/>
+                        <a:t>1.00</a:t>
+                      </a:r>
+                    </a:p>
+                  </a:txBody>
+                  <a:tcPr anchor="ctr">
+                    <a:lnL w="12700" cap="flat" cmpd="sng" algn="ctr">
+                      <a:solidFill>
+                        <a:schemeClr val="tx1"/>
+                      </a:solidFill>
+                      <a:prstDash val="solid"/>
+                      <a:round/>
+                      <a:headEnd type="none" w="med" len="med"/>
+                      <a:tailEnd type="none" w="med" len="med"/>
+                    </a:lnL>
+                    <a:lnR w="12700" cap="flat" cmpd="sng" algn="ctr">
+                      <a:solidFill>
+                        <a:schemeClr val="tx1"/>
+                      </a:solidFill>
+                      <a:prstDash val="solid"/>
+                      <a:round/>
+                      <a:headEnd type="none" w="med" len="med"/>
+                      <a:tailEnd type="none" w="med" len="med"/>
+                    </a:lnR>
+                    <a:lnT w="12700" cap="flat" cmpd="sng" algn="ctr">
+                      <a:solidFill>
+                        <a:schemeClr val="tx1"/>
+                      </a:solidFill>
+                      <a:prstDash val="solid"/>
+                      <a:round/>
+                      <a:headEnd type="none" w="med" len="med"/>
+                      <a:tailEnd type="none" w="med" len="med"/>
+                    </a:lnT>
+                    <a:lnB w="12700" cap="flat" cmpd="sng" algn="ctr">
+                      <a:solidFill>
+                        <a:schemeClr val="tx1"/>
+                      </a:solidFill>
+                      <a:prstDash val="solid"/>
+                      <a:round/>
+                      <a:headEnd type="none" w="med" len="med"/>
+                      <a:tailEnd type="none" w="med" len="med"/>
+                    </a:lnB>
+                    <a:noFill/>
+                  </a:tcPr>
+                </a:tc>
+                <a:tc>
+                  <a:txBody>
+                    <a:bodyPr/>
+                    <a:lstStyle/>
+                    <a:p>
+                      <a:pPr>
+                        <a:buNone/>
+                      </a:pPr>
+                      <a:r>
+                        <a:rPr lang="en-GB" dirty="0"/>
+                        <a:t>1.00</a:t>
+                      </a:r>
+                    </a:p>
+                  </a:txBody>
+                  <a:tcPr anchor="ctr">
+                    <a:lnL w="12700" cap="flat" cmpd="sng" algn="ctr">
+                      <a:solidFill>
+                        <a:schemeClr val="tx1"/>
+                      </a:solidFill>
+                      <a:prstDash val="solid"/>
+                      <a:round/>
+                      <a:headEnd type="none" w="med" len="med"/>
+                      <a:tailEnd type="none" w="med" len="med"/>
+                    </a:lnL>
+                    <a:lnR w="12700" cap="flat" cmpd="sng" algn="ctr">
+                      <a:solidFill>
+                        <a:schemeClr val="tx1"/>
+                      </a:solidFill>
+                      <a:prstDash val="solid"/>
+                      <a:round/>
+                      <a:headEnd type="none" w="med" len="med"/>
+                      <a:tailEnd type="none" w="med" len="med"/>
+                    </a:lnR>
+                    <a:lnT w="12700" cap="flat" cmpd="sng" algn="ctr">
+                      <a:solidFill>
+                        <a:schemeClr val="tx1"/>
+                      </a:solidFill>
+                      <a:prstDash val="solid"/>
+                      <a:round/>
+                      <a:headEnd type="none" w="med" len="med"/>
+                      <a:tailEnd type="none" w="med" len="med"/>
+                    </a:lnT>
+                    <a:lnB w="12700" cap="flat" cmpd="sng" algn="ctr">
+                      <a:solidFill>
+                        <a:schemeClr val="tx1"/>
+                      </a:solidFill>
+                      <a:prstDash val="solid"/>
+                      <a:round/>
+                      <a:headEnd type="none" w="med" len="med"/>
+                      <a:tailEnd type="none" w="med" len="med"/>
+                    </a:lnB>
+                    <a:noFill/>
+                  </a:tcPr>
+                </a:tc>
+                <a:tc>
+                  <a:txBody>
+                    <a:bodyPr/>
+                    <a:lstStyle/>
+                    <a:p>
+                      <a:pPr>
+                        <a:buNone/>
+                      </a:pPr>
+                      <a:r>
+                        <a:rPr lang="en-GB" dirty="0"/>
+                        <a:t>4696</a:t>
+                      </a:r>
+                    </a:p>
+                  </a:txBody>
+                  <a:tcPr anchor="ctr">
+                    <a:lnL w="12700" cap="flat" cmpd="sng" algn="ctr">
+                      <a:solidFill>
+                        <a:schemeClr val="tx1"/>
+                      </a:solidFill>
+                      <a:prstDash val="solid"/>
+                      <a:round/>
+                      <a:headEnd type="none" w="med" len="med"/>
+                      <a:tailEnd type="none" w="med" len="med"/>
+                    </a:lnL>
+                    <a:lnR w="12700" cap="flat" cmpd="sng" algn="ctr">
+                      <a:solidFill>
+                        <a:schemeClr val="tx1"/>
+                      </a:solidFill>
+                      <a:prstDash val="solid"/>
+                      <a:round/>
+                      <a:headEnd type="none" w="med" len="med"/>
+                      <a:tailEnd type="none" w="med" len="med"/>
+                    </a:lnR>
+                    <a:lnT w="12700" cap="flat" cmpd="sng" algn="ctr">
+                      <a:solidFill>
+                        <a:schemeClr val="tx1"/>
+                      </a:solidFill>
+                      <a:prstDash val="solid"/>
+                      <a:round/>
+                      <a:headEnd type="none" w="med" len="med"/>
+                      <a:tailEnd type="none" w="med" len="med"/>
+                    </a:lnT>
+                    <a:lnB w="12700" cap="flat" cmpd="sng" algn="ctr">
+                      <a:solidFill>
+                        <a:schemeClr val="tx1"/>
+                      </a:solidFill>
+                      <a:prstDash val="solid"/>
+                      <a:round/>
+                      <a:headEnd type="none" w="med" len="med"/>
+                      <a:tailEnd type="none" w="med" len="med"/>
+                    </a:lnB>
+                    <a:noFill/>
+                  </a:tcPr>
+                </a:tc>
+                <a:extLst>
+                  <a:ext uri="{0D108BD9-81ED-4DB2-BD59-A6C34878D82A}">
+                    <a16:rowId xmlns:a16="http://schemas.microsoft.com/office/drawing/2014/main" val="678278828"/>
+                  </a:ext>
+                </a:extLst>
+              </a:tr>
+              <a:tr h="334707">
+                <a:tc>
+                  <a:txBody>
+                    <a:bodyPr/>
+                    <a:lstStyle/>
+                    <a:p>
+                      <a:pPr>
+                        <a:buNone/>
+                      </a:pPr>
+                      <a:r>
+                        <a:rPr lang="en-GB" b="1" dirty="0"/>
+                        <a:t>Accuracy</a:t>
+                      </a:r>
+                      <a:endParaRPr lang="en-GB" dirty="0"/>
+                    </a:p>
+                  </a:txBody>
+                  <a:tcPr anchor="ctr">
+                    <a:lnL w="12700" cap="flat" cmpd="sng" algn="ctr">
+                      <a:solidFill>
+                        <a:schemeClr val="tx1"/>
+                      </a:solidFill>
+                      <a:prstDash val="solid"/>
+                      <a:round/>
+                      <a:headEnd type="none" w="med" len="med"/>
+                      <a:tailEnd type="none" w="med" len="med"/>
+                    </a:lnL>
+                    <a:lnR w="12700" cap="flat" cmpd="sng" algn="ctr">
+                      <a:solidFill>
+                        <a:schemeClr val="tx1"/>
+                      </a:solidFill>
+                      <a:prstDash val="solid"/>
+                      <a:round/>
+                      <a:headEnd type="none" w="med" len="med"/>
+                      <a:tailEnd type="none" w="med" len="med"/>
+                    </a:lnR>
+                    <a:lnT w="12700" cap="flat" cmpd="sng" algn="ctr">
+                      <a:solidFill>
+                        <a:schemeClr val="tx1"/>
+                      </a:solidFill>
+                      <a:prstDash val="solid"/>
+                      <a:round/>
+                      <a:headEnd type="none" w="med" len="med"/>
+                      <a:tailEnd type="none" w="med" len="med"/>
+                    </a:lnT>
+                    <a:lnB w="12700" cap="flat" cmpd="sng" algn="ctr">
+                      <a:solidFill>
+                        <a:schemeClr val="tx1"/>
+                      </a:solidFill>
+                      <a:prstDash val="solid"/>
+                      <a:round/>
+                      <a:headEnd type="none" w="med" len="med"/>
+                      <a:tailEnd type="none" w="med" len="med"/>
+                    </a:lnB>
+                    <a:noFill/>
+                  </a:tcPr>
+                </a:tc>
+                <a:tc>
+                  <a:txBody>
+                    <a:bodyPr/>
+                    <a:lstStyle/>
+                    <a:p>
+                      <a:pPr>
+                        <a:buNone/>
+                      </a:pPr>
+                      <a:r>
+                        <a:rPr lang="en-GB" dirty="0"/>
+                        <a:t>-</a:t>
+                      </a:r>
+                    </a:p>
+                  </a:txBody>
+                  <a:tcPr anchor="ctr">
+                    <a:lnL w="12700" cap="flat" cmpd="sng" algn="ctr">
+                      <a:solidFill>
+                        <a:schemeClr val="tx1"/>
+                      </a:solidFill>
+                      <a:prstDash val="solid"/>
+                      <a:round/>
+                      <a:headEnd type="none" w="med" len="med"/>
+                      <a:tailEnd type="none" w="med" len="med"/>
+                    </a:lnL>
+                    <a:lnR w="12700" cap="flat" cmpd="sng" algn="ctr">
+                      <a:solidFill>
+                        <a:schemeClr val="tx1"/>
+                      </a:solidFill>
+                      <a:prstDash val="solid"/>
+                      <a:round/>
+                      <a:headEnd type="none" w="med" len="med"/>
+                      <a:tailEnd type="none" w="med" len="med"/>
+                    </a:lnR>
+                    <a:lnT w="12700" cap="flat" cmpd="sng" algn="ctr">
+                      <a:solidFill>
+                        <a:schemeClr val="tx1"/>
+                      </a:solidFill>
+                      <a:prstDash val="solid"/>
+                      <a:round/>
+                      <a:headEnd type="none" w="med" len="med"/>
+                      <a:tailEnd type="none" w="med" len="med"/>
+                    </a:lnT>
+                    <a:lnB w="12700" cap="flat" cmpd="sng" algn="ctr">
+                      <a:solidFill>
+                        <a:schemeClr val="tx1"/>
+                      </a:solidFill>
+                      <a:prstDash val="solid"/>
+                      <a:round/>
+                      <a:headEnd type="none" w="med" len="med"/>
+                      <a:tailEnd type="none" w="med" len="med"/>
+                    </a:lnB>
+                    <a:noFill/>
+                  </a:tcPr>
+                </a:tc>
+                <a:tc>
+                  <a:txBody>
+                    <a:bodyPr/>
+                    <a:lstStyle/>
+                    <a:p>
+                      <a:pPr>
+                        <a:buNone/>
+                      </a:pPr>
+                      <a:r>
+                        <a:rPr lang="en-GB" dirty="0"/>
+                        <a:t>-</a:t>
+                      </a:r>
+                    </a:p>
+                  </a:txBody>
+                  <a:tcPr anchor="ctr">
+                    <a:lnL w="12700" cap="flat" cmpd="sng" algn="ctr">
+                      <a:solidFill>
+                        <a:schemeClr val="tx1"/>
+                      </a:solidFill>
+                      <a:prstDash val="solid"/>
+                      <a:round/>
+                      <a:headEnd type="none" w="med" len="med"/>
+                      <a:tailEnd type="none" w="med" len="med"/>
+                    </a:lnL>
+                    <a:lnR w="12700" cap="flat" cmpd="sng" algn="ctr">
+                      <a:solidFill>
+                        <a:schemeClr val="tx1"/>
+                      </a:solidFill>
+                      <a:prstDash val="solid"/>
+                      <a:round/>
+                      <a:headEnd type="none" w="med" len="med"/>
+                      <a:tailEnd type="none" w="med" len="med"/>
+                    </a:lnR>
+                    <a:lnT w="12700" cap="flat" cmpd="sng" algn="ctr">
+                      <a:solidFill>
+                        <a:schemeClr val="tx1"/>
+                      </a:solidFill>
+                      <a:prstDash val="solid"/>
+                      <a:round/>
+                      <a:headEnd type="none" w="med" len="med"/>
+                      <a:tailEnd type="none" w="med" len="med"/>
+                    </a:lnT>
+                    <a:lnB w="12700" cap="flat" cmpd="sng" algn="ctr">
+                      <a:solidFill>
+                        <a:schemeClr val="tx1"/>
+                      </a:solidFill>
+                      <a:prstDash val="solid"/>
+                      <a:round/>
+                      <a:headEnd type="none" w="med" len="med"/>
+                      <a:tailEnd type="none" w="med" len="med"/>
+                    </a:lnB>
+                    <a:noFill/>
+                  </a:tcPr>
+                </a:tc>
+                <a:tc>
+                  <a:txBody>
+                    <a:bodyPr/>
+                    <a:lstStyle/>
+                    <a:p>
+                      <a:pPr>
+                        <a:buNone/>
+                      </a:pPr>
+                      <a:r>
+                        <a:rPr lang="en-GB" dirty="0"/>
+                        <a:t>1.00</a:t>
+                      </a:r>
+                    </a:p>
+                  </a:txBody>
+                  <a:tcPr anchor="ctr">
+                    <a:lnL w="12700" cap="flat" cmpd="sng" algn="ctr">
+                      <a:solidFill>
+                        <a:schemeClr val="tx1"/>
+                      </a:solidFill>
+                      <a:prstDash val="solid"/>
+                      <a:round/>
+                      <a:headEnd type="none" w="med" len="med"/>
+                      <a:tailEnd type="none" w="med" len="med"/>
+                    </a:lnL>
+                    <a:lnR w="12700" cap="flat" cmpd="sng" algn="ctr">
+                      <a:solidFill>
+                        <a:schemeClr val="tx1"/>
+                      </a:solidFill>
+                      <a:prstDash val="solid"/>
+                      <a:round/>
+                      <a:headEnd type="none" w="med" len="med"/>
+                      <a:tailEnd type="none" w="med" len="med"/>
+                    </a:lnR>
+                    <a:lnT w="12700" cap="flat" cmpd="sng" algn="ctr">
+                      <a:solidFill>
+                        <a:schemeClr val="tx1"/>
+                      </a:solidFill>
+                      <a:prstDash val="solid"/>
+                      <a:round/>
+                      <a:headEnd type="none" w="med" len="med"/>
+                      <a:tailEnd type="none" w="med" len="med"/>
+                    </a:lnT>
+                    <a:lnB w="12700" cap="flat" cmpd="sng" algn="ctr">
+                      <a:solidFill>
+                        <a:schemeClr val="tx1"/>
+                      </a:solidFill>
+                      <a:prstDash val="solid"/>
+                      <a:round/>
+                      <a:headEnd type="none" w="med" len="med"/>
+                      <a:tailEnd type="none" w="med" len="med"/>
+                    </a:lnB>
+                    <a:noFill/>
+                  </a:tcPr>
+                </a:tc>
+                <a:tc>
+                  <a:txBody>
+                    <a:bodyPr/>
+                    <a:lstStyle/>
+                    <a:p>
+                      <a:pPr>
+                        <a:buNone/>
+                      </a:pPr>
+                      <a:r>
+                        <a:rPr lang="en-GB" dirty="0"/>
+                        <a:t>8980</a:t>
+                      </a:r>
+                    </a:p>
+                  </a:txBody>
+                  <a:tcPr anchor="ctr">
+                    <a:lnL w="12700" cap="flat" cmpd="sng" algn="ctr">
+                      <a:solidFill>
+                        <a:schemeClr val="tx1"/>
+                      </a:solidFill>
+                      <a:prstDash val="solid"/>
+                      <a:round/>
+                      <a:headEnd type="none" w="med" len="med"/>
+                      <a:tailEnd type="none" w="med" len="med"/>
+                    </a:lnL>
+                    <a:lnR w="12700" cap="flat" cmpd="sng" algn="ctr">
+                      <a:solidFill>
+                        <a:schemeClr val="tx1"/>
+                      </a:solidFill>
+                      <a:prstDash val="solid"/>
+                      <a:round/>
+                      <a:headEnd type="none" w="med" len="med"/>
+                      <a:tailEnd type="none" w="med" len="med"/>
+                    </a:lnR>
+                    <a:lnT w="12700" cap="flat" cmpd="sng" algn="ctr">
+                      <a:solidFill>
+                        <a:schemeClr val="tx1"/>
+                      </a:solidFill>
+                      <a:prstDash val="solid"/>
+                      <a:round/>
+                      <a:headEnd type="none" w="med" len="med"/>
+                      <a:tailEnd type="none" w="med" len="med"/>
+                    </a:lnT>
+                    <a:lnB w="12700" cap="flat" cmpd="sng" algn="ctr">
+                      <a:solidFill>
+                        <a:schemeClr val="tx1"/>
+                      </a:solidFill>
+                      <a:prstDash val="solid"/>
+                      <a:round/>
+                      <a:headEnd type="none" w="med" len="med"/>
+                      <a:tailEnd type="none" w="med" len="med"/>
+                    </a:lnB>
+                    <a:noFill/>
+                  </a:tcPr>
+                </a:tc>
+                <a:extLst>
+                  <a:ext uri="{0D108BD9-81ED-4DB2-BD59-A6C34878D82A}">
+                    <a16:rowId xmlns:a16="http://schemas.microsoft.com/office/drawing/2014/main" val="3442233651"/>
+                  </a:ext>
+                </a:extLst>
+              </a:tr>
+              <a:tr h="334707">
+                <a:tc>
+                  <a:txBody>
+                    <a:bodyPr/>
+                    <a:lstStyle/>
+                    <a:p>
+                      <a:pPr>
+                        <a:buNone/>
+                      </a:pPr>
+                      <a:r>
+                        <a:rPr lang="en-GB" b="1" dirty="0"/>
+                        <a:t>Macro </a:t>
+                      </a:r>
+                      <a:r>
+                        <a:rPr lang="en-GB" b="1" dirty="0" err="1"/>
+                        <a:t>Avg</a:t>
+                      </a:r>
+                      <a:endParaRPr lang="en-GB" dirty="0"/>
+                    </a:p>
+                  </a:txBody>
+                  <a:tcPr anchor="ctr">
+                    <a:lnL w="12700" cap="flat" cmpd="sng" algn="ctr">
+                      <a:solidFill>
+                        <a:schemeClr val="tx1"/>
+                      </a:solidFill>
+                      <a:prstDash val="solid"/>
+                      <a:round/>
+                      <a:headEnd type="none" w="med" len="med"/>
+                      <a:tailEnd type="none" w="med" len="med"/>
+                    </a:lnL>
+                    <a:lnR w="12700" cap="flat" cmpd="sng" algn="ctr">
+                      <a:solidFill>
+                        <a:schemeClr val="tx1"/>
+                      </a:solidFill>
+                      <a:prstDash val="solid"/>
+                      <a:round/>
+                      <a:headEnd type="none" w="med" len="med"/>
+                      <a:tailEnd type="none" w="med" len="med"/>
+                    </a:lnR>
+                    <a:lnT w="12700" cap="flat" cmpd="sng" algn="ctr">
+                      <a:solidFill>
+                        <a:schemeClr val="tx1"/>
+                      </a:solidFill>
+                      <a:prstDash val="solid"/>
+                      <a:round/>
+                      <a:headEnd type="none" w="med" len="med"/>
+                      <a:tailEnd type="none" w="med" len="med"/>
+                    </a:lnT>
+                    <a:lnB w="12700" cap="flat" cmpd="sng" algn="ctr">
+                      <a:solidFill>
+                        <a:schemeClr val="tx1"/>
+                      </a:solidFill>
+                      <a:prstDash val="solid"/>
+                      <a:round/>
+                      <a:headEnd type="none" w="med" len="med"/>
+                      <a:tailEnd type="none" w="med" len="med"/>
+                    </a:lnB>
+                    <a:noFill/>
+                  </a:tcPr>
+                </a:tc>
+                <a:tc>
+                  <a:txBody>
+                    <a:bodyPr/>
+                    <a:lstStyle/>
+                    <a:p>
+                      <a:pPr>
+                        <a:buNone/>
+                      </a:pPr>
+                      <a:r>
+                        <a:rPr lang="en-GB" dirty="0"/>
+                        <a:t>1.00</a:t>
+                      </a:r>
+                    </a:p>
+                  </a:txBody>
+                  <a:tcPr anchor="ctr">
+                    <a:lnL w="12700" cap="flat" cmpd="sng" algn="ctr">
+                      <a:solidFill>
+                        <a:schemeClr val="tx1"/>
+                      </a:solidFill>
+                      <a:prstDash val="solid"/>
+                      <a:round/>
+                      <a:headEnd type="none" w="med" len="med"/>
+                      <a:tailEnd type="none" w="med" len="med"/>
+                    </a:lnL>
+                    <a:lnR w="12700" cap="flat" cmpd="sng" algn="ctr">
+                      <a:solidFill>
+                        <a:schemeClr val="tx1"/>
+                      </a:solidFill>
+                      <a:prstDash val="solid"/>
+                      <a:round/>
+                      <a:headEnd type="none" w="med" len="med"/>
+                      <a:tailEnd type="none" w="med" len="med"/>
+                    </a:lnR>
+                    <a:lnT w="12700" cap="flat" cmpd="sng" algn="ctr">
+                      <a:solidFill>
+                        <a:schemeClr val="tx1"/>
+                      </a:solidFill>
+                      <a:prstDash val="solid"/>
+                      <a:round/>
+                      <a:headEnd type="none" w="med" len="med"/>
+                      <a:tailEnd type="none" w="med" len="med"/>
+                    </a:lnT>
+                    <a:lnB w="12700" cap="flat" cmpd="sng" algn="ctr">
+                      <a:solidFill>
+                        <a:schemeClr val="tx1"/>
+                      </a:solidFill>
+                      <a:prstDash val="solid"/>
+                      <a:round/>
+                      <a:headEnd type="none" w="med" len="med"/>
+                      <a:tailEnd type="none" w="med" len="med"/>
+                    </a:lnB>
+                    <a:noFill/>
+                  </a:tcPr>
+                </a:tc>
+                <a:tc>
+                  <a:txBody>
+                    <a:bodyPr/>
+                    <a:lstStyle/>
+                    <a:p>
+                      <a:pPr>
+                        <a:buNone/>
+                      </a:pPr>
+                      <a:r>
+                        <a:rPr lang="en-GB" dirty="0"/>
+                        <a:t>1.00</a:t>
+                      </a:r>
+                    </a:p>
+                  </a:txBody>
+                  <a:tcPr anchor="ctr">
+                    <a:lnL w="12700" cap="flat" cmpd="sng" algn="ctr">
+                      <a:solidFill>
+                        <a:schemeClr val="tx1"/>
+                      </a:solidFill>
+                      <a:prstDash val="solid"/>
+                      <a:round/>
+                      <a:headEnd type="none" w="med" len="med"/>
+                      <a:tailEnd type="none" w="med" len="med"/>
+                    </a:lnL>
+                    <a:lnR w="12700" cap="flat" cmpd="sng" algn="ctr">
+                      <a:solidFill>
+                        <a:schemeClr val="tx1"/>
+                      </a:solidFill>
+                      <a:prstDash val="solid"/>
+                      <a:round/>
+                      <a:headEnd type="none" w="med" len="med"/>
+                      <a:tailEnd type="none" w="med" len="med"/>
+                    </a:lnR>
+                    <a:lnT w="12700" cap="flat" cmpd="sng" algn="ctr">
+                      <a:solidFill>
+                        <a:schemeClr val="tx1"/>
+                      </a:solidFill>
+                      <a:prstDash val="solid"/>
+                      <a:round/>
+                      <a:headEnd type="none" w="med" len="med"/>
+                      <a:tailEnd type="none" w="med" len="med"/>
+                    </a:lnT>
+                    <a:lnB w="12700" cap="flat" cmpd="sng" algn="ctr">
+                      <a:solidFill>
+                        <a:schemeClr val="tx1"/>
+                      </a:solidFill>
+                      <a:prstDash val="solid"/>
+                      <a:round/>
+                      <a:headEnd type="none" w="med" len="med"/>
+                      <a:tailEnd type="none" w="med" len="med"/>
+                    </a:lnB>
+                    <a:noFill/>
+                  </a:tcPr>
+                </a:tc>
+                <a:tc>
+                  <a:txBody>
+                    <a:bodyPr/>
+                    <a:lstStyle/>
+                    <a:p>
+                      <a:pPr>
+                        <a:buNone/>
+                      </a:pPr>
+                      <a:r>
+                        <a:rPr lang="en-GB" dirty="0"/>
+                        <a:t>1.00</a:t>
+                      </a:r>
+                    </a:p>
+                  </a:txBody>
+                  <a:tcPr anchor="ctr">
+                    <a:lnL w="12700" cap="flat" cmpd="sng" algn="ctr">
+                      <a:solidFill>
+                        <a:schemeClr val="tx1"/>
+                      </a:solidFill>
+                      <a:prstDash val="solid"/>
+                      <a:round/>
+                      <a:headEnd type="none" w="med" len="med"/>
+                      <a:tailEnd type="none" w="med" len="med"/>
+                    </a:lnL>
+                    <a:lnR w="12700" cap="flat" cmpd="sng" algn="ctr">
+                      <a:solidFill>
+                        <a:schemeClr val="tx1"/>
+                      </a:solidFill>
+                      <a:prstDash val="solid"/>
+                      <a:round/>
+                      <a:headEnd type="none" w="med" len="med"/>
+                      <a:tailEnd type="none" w="med" len="med"/>
+                    </a:lnR>
+                    <a:lnT w="12700" cap="flat" cmpd="sng" algn="ctr">
+                      <a:solidFill>
+                        <a:schemeClr val="tx1"/>
+                      </a:solidFill>
+                      <a:prstDash val="solid"/>
+                      <a:round/>
+                      <a:headEnd type="none" w="med" len="med"/>
+                      <a:tailEnd type="none" w="med" len="med"/>
+                    </a:lnT>
+                    <a:lnB w="12700" cap="flat" cmpd="sng" algn="ctr">
+                      <a:solidFill>
+                        <a:schemeClr val="tx1"/>
+                      </a:solidFill>
+                      <a:prstDash val="solid"/>
+                      <a:round/>
+                      <a:headEnd type="none" w="med" len="med"/>
+                      <a:tailEnd type="none" w="med" len="med"/>
+                    </a:lnB>
+                    <a:noFill/>
+                  </a:tcPr>
+                </a:tc>
+                <a:tc>
+                  <a:txBody>
+                    <a:bodyPr/>
+                    <a:lstStyle/>
+                    <a:p>
+                      <a:pPr>
+                        <a:buNone/>
+                      </a:pPr>
+                      <a:r>
+                        <a:rPr lang="en-GB" dirty="0"/>
                         <a:t>8980</a:t>
                       </a:r>
                     </a:p>
@@ -5328,118 +7145,14 @@
                         <a:buNone/>
                       </a:pPr>
                       <a:r>
-                        <a:rPr lang="en-GB" b="1"/>
-                        <a:t>Weighted Avg</a:t>
+                        <a:rPr lang="en-GB" b="1" dirty="0"/>
+                        <a:t>Weighted </a:t>
                       </a:r>
-                      <a:endParaRPr lang="en-GB"/>
-                    </a:p>
-                  </a:txBody>
-                  <a:tcPr anchor="ctr">
-                    <a:lnL w="12700" cap="flat" cmpd="sng" algn="ctr">
-                      <a:solidFill>
-                        <a:schemeClr val="tx1"/>
-                      </a:solidFill>
-                      <a:prstDash val="solid"/>
-                      <a:round/>
-                      <a:headEnd type="none" w="med" len="med"/>
-                      <a:tailEnd type="none" w="med" len="med"/>
-                    </a:lnL>
-                    <a:lnR w="12700" cap="flat" cmpd="sng" algn="ctr">
-                      <a:solidFill>
-                        <a:schemeClr val="tx1"/>
-                      </a:solidFill>
-                      <a:prstDash val="solid"/>
-                      <a:round/>
-                      <a:headEnd type="none" w="med" len="med"/>
-                      <a:tailEnd type="none" w="med" len="med"/>
-                    </a:lnR>
-                    <a:lnT w="12700" cap="flat" cmpd="sng" algn="ctr">
-                      <a:solidFill>
-                        <a:schemeClr val="tx1"/>
-                      </a:solidFill>
-                      <a:prstDash val="solid"/>
-                      <a:round/>
-                      <a:headEnd type="none" w="med" len="med"/>
-                      <a:tailEnd type="none" w="med" len="med"/>
-                    </a:lnT>
-                    <a:lnB w="12700" cap="flat" cmpd="sng" algn="ctr">
-                      <a:solidFill>
-                        <a:schemeClr val="tx1"/>
-                      </a:solidFill>
-                      <a:prstDash val="solid"/>
-                      <a:round/>
-                      <a:headEnd type="none" w="med" len="med"/>
-                      <a:tailEnd type="none" w="med" len="med"/>
-                    </a:lnB>
-                    <a:noFill/>
-                  </a:tcPr>
-                </a:tc>
-                <a:tc>
-                  <a:txBody>
-                    <a:bodyPr/>
-                    <a:lstStyle/>
-                    <a:p>
-                      <a:pPr>
-                        <a:buNone/>
-                      </a:pPr>
                       <a:r>
-                        <a:rPr lang="en-GB"/>
-                        <a:t>1.00</a:t>
+                        <a:rPr lang="en-GB" b="1" dirty="0" err="1"/>
+                        <a:t>Avg</a:t>
                       </a:r>
-                    </a:p>
-                  </a:txBody>
-                  <a:tcPr anchor="ctr">
-                    <a:lnL w="12700" cap="flat" cmpd="sng" algn="ctr">
-                      <a:solidFill>
-                        <a:schemeClr val="tx1"/>
-                      </a:solidFill>
-                      <a:prstDash val="solid"/>
-                      <a:round/>
-                      <a:headEnd type="none" w="med" len="med"/>
-                      <a:tailEnd type="none" w="med" len="med"/>
-                    </a:lnL>
-                    <a:lnR w="12700" cap="flat" cmpd="sng" algn="ctr">
-                      <a:solidFill>
-                        <a:schemeClr val="tx1"/>
-                      </a:solidFill>
-                      <a:prstDash val="solid"/>
-                      <a:round/>
-                      <a:headEnd type="none" w="med" len="med"/>
-                      <a:tailEnd type="none" w="med" len="med"/>
-                    </a:lnR>
-                    <a:lnT w="12700" cap="flat" cmpd="sng" algn="ctr">
-                      <a:solidFill>
-                        <a:schemeClr val="tx1"/>
-                      </a:solidFill>
-                      <a:prstDash val="solid"/>
-                      <a:round/>
-                      <a:headEnd type="none" w="med" len="med"/>
-                      <a:tailEnd type="none" w="med" len="med"/>
-                    </a:lnT>
-                    <a:lnB w="12700" cap="flat" cmpd="sng" algn="ctr">
-                      <a:solidFill>
-                        <a:schemeClr val="tx1"/>
-                      </a:solidFill>
-                      <a:prstDash val="solid"/>
-                      <a:round/>
-                      <a:headEnd type="none" w="med" len="med"/>
-                      <a:tailEnd type="none" w="med" len="med"/>
-                    </a:lnB>
-                    <a:noFill/>
-                  </a:tcPr>
-                </a:tc>
-                <a:tc>
-                  <a:txBody>
-                    <a:bodyPr/>
-                    <a:lstStyle/>
-                    <a:p>
-                      <a:pPr>
-                        <a:buNone/>
-                      </a:pPr>
-                      <a:r>
-                        <a:rPr lang="en-GB"/>
-                        <a:t>1.00</a:t>
-                      </a:r>
+                      <a:endParaRPr lang="en-GB" dirty="0"/>
                     </a:p>
                   </a:txBody>
                   <a:tcPr anchor="ctr">
@@ -5546,6 +7259,114 @@
                       </a:pPr>
                       <a:r>
                         <a:rPr lang="en-GB" dirty="0"/>
+                        <a:t>1.00</a:t>
+                      </a:r>
+                    </a:p>
+                  </a:txBody>
+                  <a:tcPr anchor="ctr">
+                    <a:lnL w="12700" cap="flat" cmpd="sng" algn="ctr">
+                      <a:solidFill>
+                        <a:schemeClr val="tx1"/>
+                      </a:solidFill>
+                      <a:prstDash val="solid"/>
+                      <a:round/>
+                      <a:headEnd type="none" w="med" len="med"/>
+                      <a:tailEnd type="none" w="med" len="med"/>
+                    </a:lnL>
+                    <a:lnR w="12700" cap="flat" cmpd="sng" algn="ctr">
+                      <a:solidFill>
+                        <a:schemeClr val="tx1"/>
+                      </a:solidFill>
+                      <a:prstDash val="solid"/>
+                      <a:round/>
+                      <a:headEnd type="none" w="med" len="med"/>
+                      <a:tailEnd type="none" w="med" len="med"/>
+                    </a:lnR>
+                    <a:lnT w="12700" cap="flat" cmpd="sng" algn="ctr">
+                      <a:solidFill>
+                        <a:schemeClr val="tx1"/>
+                      </a:solidFill>
+                      <a:prstDash val="solid"/>
+                      <a:round/>
+                      <a:headEnd type="none" w="med" len="med"/>
+                      <a:tailEnd type="none" w="med" len="med"/>
+                    </a:lnT>
+                    <a:lnB w="12700" cap="flat" cmpd="sng" algn="ctr">
+                      <a:solidFill>
+                        <a:schemeClr val="tx1"/>
+                      </a:solidFill>
+                      <a:prstDash val="solid"/>
+                      <a:round/>
+                      <a:headEnd type="none" w="med" len="med"/>
+                      <a:tailEnd type="none" w="med" len="med"/>
+                    </a:lnB>
+                    <a:noFill/>
+                  </a:tcPr>
+                </a:tc>
+                <a:tc>
+                  <a:txBody>
+                    <a:bodyPr/>
+                    <a:lstStyle/>
+                    <a:p>
+                      <a:pPr>
+                        <a:buNone/>
+                      </a:pPr>
+                      <a:r>
+                        <a:rPr lang="en-GB" dirty="0"/>
+                        <a:t>1.00</a:t>
+                      </a:r>
+                    </a:p>
+                  </a:txBody>
+                  <a:tcPr anchor="ctr">
+                    <a:lnL w="12700" cap="flat" cmpd="sng" algn="ctr">
+                      <a:solidFill>
+                        <a:schemeClr val="tx1"/>
+                      </a:solidFill>
+                      <a:prstDash val="solid"/>
+                      <a:round/>
+                      <a:headEnd type="none" w="med" len="med"/>
+                      <a:tailEnd type="none" w="med" len="med"/>
+                    </a:lnL>
+                    <a:lnR w="12700" cap="flat" cmpd="sng" algn="ctr">
+                      <a:solidFill>
+                        <a:schemeClr val="tx1"/>
+                      </a:solidFill>
+                      <a:prstDash val="solid"/>
+                      <a:round/>
+                      <a:headEnd type="none" w="med" len="med"/>
+                      <a:tailEnd type="none" w="med" len="med"/>
+                    </a:lnR>
+                    <a:lnT w="12700" cap="flat" cmpd="sng" algn="ctr">
+                      <a:solidFill>
+                        <a:schemeClr val="tx1"/>
+                      </a:solidFill>
+                      <a:prstDash val="solid"/>
+                      <a:round/>
+                      <a:headEnd type="none" w="med" len="med"/>
+                      <a:tailEnd type="none" w="med" len="med"/>
+                    </a:lnT>
+                    <a:lnB w="12700" cap="flat" cmpd="sng" algn="ctr">
+                      <a:solidFill>
+                        <a:schemeClr val="tx1"/>
+                      </a:solidFill>
+                      <a:prstDash val="solid"/>
+                      <a:round/>
+                      <a:headEnd type="none" w="med" len="med"/>
+                      <a:tailEnd type="none" w="med" len="med"/>
+                    </a:lnB>
+                    <a:noFill/>
+                  </a:tcPr>
+                </a:tc>
+                <a:tc>
+                  <a:txBody>
+                    <a:bodyPr/>
+                    <a:lstStyle/>
+                    <a:p>
+                      <a:pPr>
+                        <a:buNone/>
+                      </a:pPr>
+                      <a:r>
+                        <a:rPr lang="en-GB" dirty="0"/>
                         <a:t>8980</a:t>
                       </a:r>
                     </a:p>
@@ -5605,7 +7426,7 @@
           <p:cNvPr id="9" name="CuadroTexto 8">
             <a:extLst>
               <a:ext uri="{FF2B5EF4-FFF2-40B4-BE49-F238E27FC236}">
-                <a16:creationId xmlns:a16="http://schemas.microsoft.com/office/drawing/2014/main" id="{6820A762-A449-A673-EE00-36B54F6FBC27}"/>
+                <a16:creationId xmlns:a16="http://schemas.microsoft.com/office/drawing/2014/main" id="{32CD25FB-EE23-1E99-65B5-46A345D156CC}"/>
               </a:ext>
             </a:extLst>
           </p:cNvPr>
@@ -5614,7 +7435,7 @@
         </p:nvSpPr>
         <p:spPr>
           <a:xfrm>
-            <a:off x="4080389" y="2112805"/>
+            <a:off x="688260" y="2103103"/>
             <a:ext cx="4375357" cy="1323439"/>
           </a:xfrm>
           <a:prstGeom prst="rect">
@@ -5650,7 +7471,7 @@
     </p:spTree>
     <p:extLst>
       <p:ext uri="{BB962C8B-B14F-4D97-AF65-F5344CB8AC3E}">
-        <p14:creationId xmlns:p14="http://schemas.microsoft.com/office/powerpoint/2010/main" val="145002764"/>
+        <p14:creationId xmlns:p14="http://schemas.microsoft.com/office/powerpoint/2010/main" val="3129615861"/>
       </p:ext>
     </p:extLst>
   </p:cSld>
@@ -5660,7 +7481,7 @@
 </p:sld>
 </file>
 
-<file path=ppt/slides/slide15.xml><?xml version="1.0" encoding="utf-8"?>
+<file path=ppt/slides/slide16.xml><?xml version="1.0" encoding="utf-8"?>
 <p:sld xmlns:a="http://schemas.openxmlformats.org/drawingml/2006/main" xmlns:r="http://schemas.openxmlformats.org/officeDocument/2006/relationships" xmlns:p="http://schemas.openxmlformats.org/presentationml/2006/main">
   <p:cSld>
     <p:spTree>
@@ -5791,10 +7612,10 @@
       </p:sp>
       <p:pic>
         <p:nvPicPr>
-          <p:cNvPr id="10" name="Imagen 9">
+          <p:cNvPr id="6" name="Imagen 5">
             <a:extLst>
               <a:ext uri="{FF2B5EF4-FFF2-40B4-BE49-F238E27FC236}">
-                <a16:creationId xmlns:a16="http://schemas.microsoft.com/office/drawing/2014/main" id="{6A155973-C971-E855-899A-305D843CE584}"/>
+                <a16:creationId xmlns:a16="http://schemas.microsoft.com/office/drawing/2014/main" id="{64564A4B-B65C-5329-235D-C5CCC2713845}"/>
               </a:ext>
             </a:extLst>
           </p:cNvPr>
@@ -5804,21 +7625,15 @@
           <p:nvPr/>
         </p:nvPicPr>
         <p:blipFill>
-          <a:blip r:embed="rId2">
-            <a:extLst>
-              <a:ext uri="{28A0092B-C50C-407E-A947-70E740481C1C}">
-                <a14:useLocalDpi xmlns:a14="http://schemas.microsoft.com/office/drawing/2010/main" val="0"/>
-              </a:ext>
-            </a:extLst>
-          </a:blip>
+          <a:blip r:embed="rId2"/>
           <a:stretch>
             <a:fillRect/>
           </a:stretch>
         </p:blipFill>
         <p:spPr>
           <a:xfrm>
-            <a:off x="110612" y="2728255"/>
-            <a:ext cx="4528744" cy="3396557"/>
+            <a:off x="143929" y="2847965"/>
+            <a:ext cx="4462107" cy="3346580"/>
           </a:xfrm>
           <a:prstGeom prst="rect">
             <a:avLst/>
@@ -5827,10 +7642,10 @@
       </p:pic>
       <p:pic>
         <p:nvPicPr>
-          <p:cNvPr id="11" name="Imagen 10">
+          <p:cNvPr id="8" name="Imagen 7">
             <a:extLst>
               <a:ext uri="{FF2B5EF4-FFF2-40B4-BE49-F238E27FC236}">
-                <a16:creationId xmlns:a16="http://schemas.microsoft.com/office/drawing/2014/main" id="{CE48A6E2-6698-7891-E489-72FC59487F7D}"/>
+                <a16:creationId xmlns:a16="http://schemas.microsoft.com/office/drawing/2014/main" id="{31CCAA57-9947-5E63-EB6D-DF319016307C}"/>
               </a:ext>
             </a:extLst>
           </p:cNvPr>
@@ -5840,21 +7655,15 @@
           <p:nvPr/>
         </p:nvPicPr>
         <p:blipFill>
-          <a:blip r:embed="rId3">
-            <a:extLst>
-              <a:ext uri="{28A0092B-C50C-407E-A947-70E740481C1C}">
-                <a14:useLocalDpi xmlns:a14="http://schemas.microsoft.com/office/drawing/2010/main" val="0"/>
-              </a:ext>
-            </a:extLst>
-          </a:blip>
+          <a:blip r:embed="rId3"/>
           <a:stretch>
             <a:fillRect/>
           </a:stretch>
         </p:blipFill>
         <p:spPr>
           <a:xfrm>
-            <a:off x="4571281" y="2852815"/>
-            <a:ext cx="4462107" cy="3346581"/>
+            <a:off x="4572000" y="2847965"/>
+            <a:ext cx="4475041" cy="3356281"/>
           </a:xfrm>
           <a:prstGeom prst="rect">
             <a:avLst/>
@@ -5874,7 +7683,7 @@
 </p:sld>
 </file>
 
-<file path=ppt/slides/slide16.xml><?xml version="1.0" encoding="utf-8"?>
+<file path=ppt/slides/slide17.xml><?xml version="1.0" encoding="utf-8"?>
 <p:sld xmlns:a="http://schemas.openxmlformats.org/drawingml/2006/main" xmlns:r="http://schemas.openxmlformats.org/officeDocument/2006/relationships" xmlns:p="http://schemas.openxmlformats.org/presentationml/2006/main">
   <p:cSld>
     <p:spTree>
@@ -6158,7 +7967,7 @@
 </p:sld>
 </file>
 
-<file path=ppt/slides/slide17.xml><?xml version="1.0" encoding="utf-8"?>
+<file path=ppt/slides/slide18.xml><?xml version="1.0" encoding="utf-8"?>
 <p:sld xmlns:a="http://schemas.openxmlformats.org/drawingml/2006/main" xmlns:r="http://schemas.openxmlformats.org/officeDocument/2006/relationships" xmlns:p="http://schemas.openxmlformats.org/presentationml/2006/main">
   <p:cSld>
     <p:spTree>
@@ -6299,7 +8108,7 @@
 </p:sld>
 </file>
 
-<file path=ppt/slides/slide18.xml><?xml version="1.0" encoding="utf-8"?>
+<file path=ppt/slides/slide19.xml><?xml version="1.0" encoding="utf-8"?>
 <p:sld xmlns:a="http://schemas.openxmlformats.org/drawingml/2006/main" xmlns:r="http://schemas.openxmlformats.org/officeDocument/2006/relationships" xmlns:p="http://schemas.openxmlformats.org/presentationml/2006/main">
   <p:cSld>
     <p:spTree>
@@ -6332,7 +8141,7 @@
         </p:nvSpPr>
         <p:spPr>
           <a:xfrm>
-            <a:off x="1004119" y="2658063"/>
+            <a:off x="1004119" y="2766218"/>
             <a:ext cx="7135761" cy="1325563"/>
           </a:xfrm>
           <a:prstGeom prst="rect">
@@ -6359,10 +8168,9 @@
           </a:lstStyle>
           <a:p>
             <a:r>
-              <a:rPr lang="en-GB"/>
+              <a:rPr lang="en-GB" dirty="0"/>
               <a:t>Do you see anything strange?</a:t>
             </a:r>
-            <a:endParaRPr lang="en-GB" dirty="0"/>
           </a:p>
         </p:txBody>
       </p:sp>
@@ -6379,7 +8187,94 @@
 </p:sld>
 </file>
 
-<file path=ppt/slides/slide19.xml><?xml version="1.0" encoding="utf-8"?>
+<file path=ppt/slides/slide2.xml><?xml version="1.0" encoding="utf-8"?>
+<p:sld xmlns:a="http://schemas.openxmlformats.org/drawingml/2006/main" xmlns:r="http://schemas.openxmlformats.org/officeDocument/2006/relationships" xmlns:p="http://schemas.openxmlformats.org/presentationml/2006/main" show="0">
+  <p:cSld>
+    <p:spTree>
+      <p:nvGrpSpPr>
+        <p:cNvPr id="1" name=""/>
+        <p:cNvGrpSpPr/>
+        <p:nvPr/>
+      </p:nvGrpSpPr>
+      <p:grpSpPr>
+        <a:xfrm>
+          <a:off x="0" y="0"/>
+          <a:ext cx="0" cy="0"/>
+          <a:chOff x="0" y="0"/>
+          <a:chExt cx="0" cy="0"/>
+        </a:xfrm>
+      </p:grpSpPr>
+      <p:sp>
+        <p:nvSpPr>
+          <p:cNvPr id="2" name="Title 1"/>
+          <p:cNvSpPr>
+            <a:spLocks noGrp="1"/>
+          </p:cNvSpPr>
+          <p:nvPr>
+            <p:ph type="title"/>
+          </p:nvPr>
+        </p:nvSpPr>
+        <p:spPr/>
+        <p:txBody>
+          <a:bodyPr/>
+          <a:lstStyle/>
+          <a:p>
+            <a:r>
+              <a:t>Agenda</a:t>
+            </a:r>
+          </a:p>
+        </p:txBody>
+      </p:sp>
+      <p:sp>
+        <p:nvSpPr>
+          <p:cNvPr id="3" name="Content Placeholder 2"/>
+          <p:cNvSpPr>
+            <a:spLocks noGrp="1"/>
+          </p:cNvSpPr>
+          <p:nvPr>
+            <p:ph idx="1"/>
+          </p:nvPr>
+        </p:nvSpPr>
+        <p:spPr/>
+        <p:txBody>
+          <a:bodyPr/>
+          <a:lstStyle/>
+          <a:p>
+            <a:r>
+              <a:t>Task and dataset</a:t>
+            </a:r>
+          </a:p>
+          <a:p>
+            <a:r>
+              <a:t>Preprocessing and evaluation setup</a:t>
+            </a:r>
+          </a:p>
+          <a:p>
+            <a:r>
+              <a:t>Classic classifiers (simple, no SVM, no deep learning)</a:t>
+            </a:r>
+          </a:p>
+          <a:p>
+            <a:r>
+              <a:t>Results and interpretation</a:t>
+            </a:r>
+          </a:p>
+          <a:p>
+            <a:r>
+              <a:t>Subject leakage analysis</a:t>
+            </a:r>
+          </a:p>
+        </p:txBody>
+      </p:sp>
+    </p:spTree>
+  </p:cSld>
+  <p:clrMapOvr>
+    <a:masterClrMapping/>
+  </p:clrMapOvr>
+</p:sld>
+</file>
+
+<file path=ppt/slides/slide20.xml><?xml version="1.0" encoding="utf-8"?>
 <p:sld xmlns:a="http://schemas.openxmlformats.org/drawingml/2006/main" xmlns:r="http://schemas.openxmlformats.org/officeDocument/2006/relationships" xmlns:p="http://schemas.openxmlformats.org/presentationml/2006/main">
   <p:cSld>
     <p:spTree>
@@ -7014,94 +8909,7 @@
 </p:sld>
 </file>
 
-<file path=ppt/slides/slide2.xml><?xml version="1.0" encoding="utf-8"?>
-<p:sld xmlns:a="http://schemas.openxmlformats.org/drawingml/2006/main" xmlns:r="http://schemas.openxmlformats.org/officeDocument/2006/relationships" xmlns:p="http://schemas.openxmlformats.org/presentationml/2006/main" show="0">
-  <p:cSld>
-    <p:spTree>
-      <p:nvGrpSpPr>
-        <p:cNvPr id="1" name=""/>
-        <p:cNvGrpSpPr/>
-        <p:nvPr/>
-      </p:nvGrpSpPr>
-      <p:grpSpPr>
-        <a:xfrm>
-          <a:off x="0" y="0"/>
-          <a:ext cx="0" cy="0"/>
-          <a:chOff x="0" y="0"/>
-          <a:chExt cx="0" cy="0"/>
-        </a:xfrm>
-      </p:grpSpPr>
-      <p:sp>
-        <p:nvSpPr>
-          <p:cNvPr id="2" name="Title 1"/>
-          <p:cNvSpPr>
-            <a:spLocks noGrp="1"/>
-          </p:cNvSpPr>
-          <p:nvPr>
-            <p:ph type="title"/>
-          </p:nvPr>
-        </p:nvSpPr>
-        <p:spPr/>
-        <p:txBody>
-          <a:bodyPr/>
-          <a:lstStyle/>
-          <a:p>
-            <a:r>
-              <a:t>Agenda</a:t>
-            </a:r>
-          </a:p>
-        </p:txBody>
-      </p:sp>
-      <p:sp>
-        <p:nvSpPr>
-          <p:cNvPr id="3" name="Content Placeholder 2"/>
-          <p:cNvSpPr>
-            <a:spLocks noGrp="1"/>
-          </p:cNvSpPr>
-          <p:nvPr>
-            <p:ph idx="1"/>
-          </p:nvPr>
-        </p:nvSpPr>
-        <p:spPr/>
-        <p:txBody>
-          <a:bodyPr/>
-          <a:lstStyle/>
-          <a:p>
-            <a:r>
-              <a:t>Task and dataset</a:t>
-            </a:r>
-          </a:p>
-          <a:p>
-            <a:r>
-              <a:t>Preprocessing and evaluation setup</a:t>
-            </a:r>
-          </a:p>
-          <a:p>
-            <a:r>
-              <a:t>Classic classifiers (simple, no SVM, no deep learning)</a:t>
-            </a:r>
-          </a:p>
-          <a:p>
-            <a:r>
-              <a:t>Results and interpretation</a:t>
-            </a:r>
-          </a:p>
-          <a:p>
-            <a:r>
-              <a:t>Subject leakage analysis</a:t>
-            </a:r>
-          </a:p>
-        </p:txBody>
-      </p:sp>
-    </p:spTree>
-  </p:cSld>
-  <p:clrMapOvr>
-    <a:masterClrMapping/>
-  </p:clrMapOvr>
-</p:sld>
-</file>
-
-<file path=ppt/slides/slide20.xml><?xml version="1.0" encoding="utf-8"?>
+<file path=ppt/slides/slide21.xml><?xml version="1.0" encoding="utf-8"?>
 <p:sld xmlns:a="http://schemas.openxmlformats.org/drawingml/2006/main" xmlns:r="http://schemas.openxmlformats.org/officeDocument/2006/relationships" xmlns:p="http://schemas.openxmlformats.org/presentationml/2006/main">
   <p:cSld>
     <p:spTree>
@@ -7333,7 +9141,7 @@
 </p:sld>
 </file>
 
-<file path=ppt/slides/slide21.xml><?xml version="1.0" encoding="utf-8"?>
+<file path=ppt/slides/slide22.xml><?xml version="1.0" encoding="utf-8"?>
 <p:sld xmlns:a="http://schemas.openxmlformats.org/drawingml/2006/main" xmlns:r="http://schemas.openxmlformats.org/officeDocument/2006/relationships" xmlns:p="http://schemas.openxmlformats.org/presentationml/2006/main">
   <p:cSld>
     <p:spTree>
@@ -7449,8 +9257,8 @@
 </p:sld>
 </file>
 
-<file path=ppt/slides/slide22.xml><?xml version="1.0" encoding="utf-8"?>
-<p:sld xmlns:a="http://schemas.openxmlformats.org/drawingml/2006/main" xmlns:r="http://schemas.openxmlformats.org/officeDocument/2006/relationships" xmlns:p="http://schemas.openxmlformats.org/presentationml/2006/main" show="0">
+<file path=ppt/slides/slide23.xml><?xml version="1.0" encoding="utf-8"?>
+<p:sld xmlns:a="http://schemas.openxmlformats.org/drawingml/2006/main" xmlns:r="http://schemas.openxmlformats.org/officeDocument/2006/relationships" xmlns:p="http://schemas.openxmlformats.org/presentationml/2006/main">
   <p:cSld>
     <p:spTree>
       <p:nvGrpSpPr>

</xml_diff>